<commit_message>
Give the trainer deck abstract backgrounds and Asraf's brand
Generated mesh-gradient backgrounds with flowing ribbons in Asraf's
navy, purple, teal and logo cyan (make-backgrounds.py), his logo on
every layout, white cards with soft shadows, and screenshots floating
on gradient panels. The build script is renamed to .cjs so it runs
inside _design, which is an ES module package.

Co-Authored-By: Claude Opus 5.5 <noreply@anthropic.com>
Claude-Session: https://claude.ai/code/session_01DQxLb9wMt3kaDj2aX9TSiy
</commit_message>
<xml_diff>
--- a/Copilot-Chat-Basic-Workshop-Deck.pptx
+++ b/Copilot-Chat-Basic-Workshop-Deck.pptx
@@ -156,7 +156,7 @@
   <p:extLst>
     <p:ext uri="{521415D9-36F7-43E2-AB2F-B90AF26B5E84}">
       <p14:sectionLst xmlns:p14="http://schemas.microsoft.com/office/powerpoint/2010/main">
-        <p14:section name="Welcome" id="{04fc5a1e-2d1e-11f4-56c5-0903527f30bc}">
+        <p14:section name="Welcome" id="{fc0325b0-1ad6-e854-78b4-e7b29925407f}">
           <p14:sldIdLst>
             <p14:sldId id="256"/>
             <p14:sldId id="257"/>
@@ -166,7 +166,7 @@
             <p14:sldId id="261"/>
           </p14:sldIdLst>
         </p14:section>
-        <p14:section name="01 Which Copilot do I have?" id="{64599b24-5941-cfb5-b639-2274158c5ed7}">
+        <p14:section name="01 Which Copilot do I have?" id="{18497dd3-0dcf-5f4a-a772-bb6545c7db02}">
           <p14:sldIdLst>
             <p14:sldId id="262"/>
             <p14:sldId id="263"/>
@@ -175,7 +175,7 @@
             <p14:sldId id="266"/>
           </p14:sldIdLst>
         </p14:section>
-        <p14:section name="02 Find your way around" id="{d408f819-5ced-b334-418e-ae83ecc74a6c}">
+        <p14:section name="02 Find your way around" id="{e779932c-152c-0da1-4dfc-f836fb3fb178}">
           <p14:sldIdLst>
             <p14:sldId id="267"/>
             <p14:sldId id="268"/>
@@ -183,7 +183,7 @@
             <p14:sldId id="270"/>
           </p14:sldIdLst>
         </p14:section>
-        <p14:section name="03 Write better prompts" id="{30b6ea64-2345-e18d-8868-f7b25803ea31}">
+        <p14:section name="03 Write better prompts" id="{940a0c3f-e2dd-758b-0e5a-78538fa06cac}">
           <p14:sldIdLst>
             <p14:sldId id="271"/>
             <p14:sldId id="272"/>
@@ -192,7 +192,7 @@
             <p14:sldId id="275"/>
           </p14:sldIdLst>
         </p14:section>
-        <p14:section name="04 Compare the quotations" id="{bc57ea9f-ba9f-bc58-5f44-95b97dd56768}">
+        <p14:section name="04 Compare the quotations" id="{73f212ea-1e8d-6a7e-66df-ed3fb1d603c5}">
           <p14:sldIdLst>
             <p14:sldId id="276"/>
             <p14:sldId id="277"/>
@@ -202,7 +202,7 @@
             <p14:sldId id="281"/>
           </p14:sldIdLst>
         </p14:section>
-        <p14:section name="05 Chase vendors in Outlook" id="{5d198752-7849-9502-a2fb-18a2c152e6b3}">
+        <p14:section name="05 Chase vendors in Outlook" id="{97f594dc-2347-380a-3da4-550916f500f7}">
           <p14:sldIdLst>
             <p14:sldId id="282"/>
             <p14:sldId id="283"/>
@@ -210,7 +210,7 @@
             <p14:sldId id="285"/>
           </p14:sldIdLst>
         </p14:section>
-        <p14:section name="06 From chat to Pages" id="{f37bc0ab-3c7c-6d01-7ea5-aa5f90780c2a}">
+        <p14:section name="06 From chat to Pages" id="{6b0af65e-f640-afdd-c724-d47e63cc64d3}">
           <p14:sldIdLst>
             <p14:sldId id="286"/>
             <p14:sldId id="287"/>
@@ -218,14 +218,14 @@
             <p14:sldId id="289"/>
           </p14:sldIdLst>
         </p14:section>
-        <p14:section name="07 Keep it together in a Notebook" id="{c5e83646-eb0e-049b-884a-313b9c19eafd}">
+        <p14:section name="07 Keep it together in a Notebook" id="{1b04bd8a-fab1-c650-e1f9-8823137351f8}">
           <p14:sldIdLst>
             <p14:sldId id="290"/>
             <p14:sldId id="291"/>
             <p14:sldId id="292"/>
           </p14:sldIdLst>
         </p14:section>
-        <p14:section name="08 Build a Quotation Checker agent" id="{00a34bec-f495-303a-4ae9-334aaadd4aaa}">
+        <p14:section name="08 Build a Quotation Checker agent" id="{81bd0ca7-9d55-427d-7034-553733bd03dd}">
           <p14:sldIdLst>
             <p14:sldId id="293"/>
             <p14:sldId id="294"/>
@@ -234,25 +234,25 @@
             <p14:sldId id="297"/>
           </p14:sldIdLst>
         </p14:section>
-        <p14:section name="09 Optional: Word and Excel" id="{e66b274c-67f7-d31d-9c23-83adc0498293}">
+        <p14:section name="09 Optional: Word and Excel" id="{8c1b5ade-cb70-f42c-3c0b-462ccab1e194}">
           <p14:sldIdLst>
             <p14:sldId id="298"/>
             <p14:sldId id="299"/>
           </p14:sldIdLst>
         </p14:section>
-        <p14:section name="10 Capstone" id="{5dd320e1-d26b-58e0-4cb0-b8defe7f81e9}">
+        <p14:section name="10 Capstone" id="{684ca27b-6bba-4978-164f-0972b9a19426}">
           <p14:sldIdLst>
             <p14:sldId id="300"/>
             <p14:sldId id="301"/>
             <p14:sldId id="302"/>
           </p14:sldIdLst>
         </p14:section>
-        <p14:section name="11 Extra practice" id="{e40d6115-dcf1-1488-7464-f6f4283c3112}">
+        <p14:section name="11 Extra practice" id="{e1025b9e-fdd8-266d-912c-df5851b5757a}">
           <p14:sldIdLst>
             <p14:sldId id="303"/>
           </p14:sldIdLst>
         </p14:section>
-        <p14:section name="Close" id="{84b41ff1-05f9-f774-9ece-72f7c3df6814}">
+        <p14:section name="Close" id="{b1bdc88f-c111-eedf-cc1c-4413f58e6006}">
           <p14:sldIdLst>
             <p14:sldId id="304"/>
             <p14:sldId id="305"/>
@@ -5110,9 +5110,16 @@
   <p:cSld name="Title">
     <p:bg>
       <p:bgPr>
-        <a:solidFill>
-          <a:schemeClr val="tx1"/>
-        </a:solidFill>
+        <a:blipFill dpi="0" rotWithShape="1">
+          <a:blip r:embed="rId2">
+            <a:lum/>
+          </a:blip>
+          <a:srcRect/>
+          <a:stretch>
+            <a:fillRect/>
+          </a:stretch>
+        </a:blipFill>
+        <a:effectLst/>
       </p:bgPr>
     </p:bg>
     <p:spTree>
@@ -5129,12 +5136,36 @@
           <a:chExt cx="0" cy="0"/>
         </a:xfrm>
       </p:grpSpPr>
-      <p:sp>
-        <p:nvSpPr>
-          <p:cNvPr id="2" name="Text 0"/>
+      <p:pic>
+        <p:nvPicPr>
+          <p:cNvPr id="2" name="Image 0" descr="Asraf JS logo">    </p:cNvPr>
+          <p:cNvPicPr>
+            <a:picLocks noChangeAspect="1"/>
+          </p:cNvPicPr>
+          <p:nvPr/>
+        </p:nvPicPr>
+        <p:blipFill>
+          <a:blip r:embed="rId1"/>
+          <a:stretch>
+            <a:fillRect/>
+          </a:stretch>
+        </p:blipFill>
+        <p:spPr>
+          <a:xfrm>
+            <a:off x="658368" y="457200"/>
+            <a:ext cx="777240" cy="777240"/>
+          </a:xfrm>
+          <a:prstGeom prst="rect">
+            <a:avLst/>
+          </a:prstGeom>
+        </p:spPr>
+      </p:pic>
+      <p:sp>
+        <p:nvSpPr>
+          <p:cNvPr id="3" name="Text 0"/>
           <p:cNvSpPr/>
           <p:nvPr>
-            <p:ph idx="100" type="body" hasCustomPrompt="1"/>
+            <p:ph idx="101" type="body" hasCustomPrompt="1"/>
           </p:nvPr>
         </p:nvSpPr>
         <p:spPr>
@@ -5155,7 +5186,7 @@
               <a:buNone/>
               <a:defRPr lang="en-US" sz="1600" dirty="0">
                 <a:solidFill>
-                  <a:schemeClr val="bg2"/>
+                  <a:srgbClr val="00EEFC"/>
                 </a:solidFill>
               </a:defRPr>
             </a:lvl1pPr>
@@ -5170,10 +5201,10 @@
       </p:sp>
       <p:sp>
         <p:nvSpPr>
-          <p:cNvPr id="3" name="Text 0"/>
+          <p:cNvPr id="4" name="Text 0"/>
           <p:cNvSpPr/>
           <p:nvPr>
-            <p:ph idx="101" type="title" hasCustomPrompt="1"/>
+            <p:ph idx="102" type="title" hasCustomPrompt="1"/>
           </p:nvPr>
         </p:nvSpPr>
         <p:spPr>
@@ -5204,45 +5235,6 @@
               <a:buNone/>
             </a:pPr>
             <a:endParaRPr lang="en-US" sz="4800" dirty="0"/>
-          </a:p>
-        </p:txBody>
-      </p:sp>
-      <p:sp>
-        <p:nvSpPr>
-          <p:cNvPr id="4" name="Text 0"/>
-          <p:cNvSpPr/>
-          <p:nvPr>
-            <p:ph idx="102" type="body" hasCustomPrompt="1"/>
-          </p:nvPr>
-        </p:nvSpPr>
-        <p:spPr>
-          <a:xfrm>
-            <a:off x="731520" y="3383280"/>
-            <a:ext cx="9144000" cy="914400"/>
-          </a:xfrm>
-          <a:prstGeom prst="rect">
-            <a:avLst/>
-          </a:prstGeom>
-          <a:noFill/>
-          <a:ln/>
-        </p:spPr>
-        <p:txBody>
-          <a:bodyPr wrap="square" rtlCol="0"/>
-          <a:lstStyle>
-            <a:lvl1pPr indent="0" marL="0">
-              <a:buNone/>
-              <a:defRPr lang="en-US" sz="2200" dirty="0">
-                <a:solidFill>
-                  <a:schemeClr val="bg2"/>
-                </a:solidFill>
-              </a:defRPr>
-            </a:lvl1pPr>
-          </a:lstStyle>
-          <a:p>
-            <a:pPr indent="0" marL="0">
-              <a:buNone/>
-            </a:pPr>
-            <a:endParaRPr lang="en-US" sz="2200" dirty="0"/>
           </a:p>
         </p:txBody>
       </p:sp>
@@ -5252,6 +5244,45 @@
           <p:cNvSpPr/>
           <p:nvPr>
             <p:ph idx="103" type="body" hasCustomPrompt="1"/>
+          </p:nvPr>
+        </p:nvSpPr>
+        <p:spPr>
+          <a:xfrm>
+            <a:off x="731520" y="3383280"/>
+            <a:ext cx="9144000" cy="914400"/>
+          </a:xfrm>
+          <a:prstGeom prst="rect">
+            <a:avLst/>
+          </a:prstGeom>
+          <a:noFill/>
+          <a:ln/>
+        </p:spPr>
+        <p:txBody>
+          <a:bodyPr wrap="square" rtlCol="0"/>
+          <a:lstStyle>
+            <a:lvl1pPr indent="0" marL="0">
+              <a:buNone/>
+              <a:defRPr lang="en-US" sz="2200" dirty="0">
+                <a:solidFill>
+                  <a:schemeClr val="bg2"/>
+                </a:solidFill>
+              </a:defRPr>
+            </a:lvl1pPr>
+          </a:lstStyle>
+          <a:p>
+            <a:pPr indent="0" marL="0">
+              <a:buNone/>
+            </a:pPr>
+            <a:endParaRPr lang="en-US" sz="2200" dirty="0"/>
+          </a:p>
+        </p:txBody>
+      </p:sp>
+      <p:sp>
+        <p:nvSpPr>
+          <p:cNvPr id="6" name="Text 0"/>
+          <p:cNvSpPr/>
+          <p:nvPr>
+            <p:ph idx="104" type="body" hasCustomPrompt="1"/>
           </p:nvPr>
         </p:nvSpPr>
         <p:spPr>
@@ -5298,9 +5329,16 @@
   <p:cSld name="Divider">
     <p:bg>
       <p:bgPr>
-        <a:solidFill>
-          <a:schemeClr val="accent1"/>
-        </a:solidFill>
+        <a:blipFill dpi="0" rotWithShape="1">
+          <a:blip r:embed="rId2">
+            <a:lum/>
+          </a:blip>
+          <a:srcRect/>
+          <a:stretch>
+            <a:fillRect/>
+          </a:stretch>
+        </a:blipFill>
+        <a:effectLst/>
       </p:bgPr>
     </p:bg>
     <p:spTree>
@@ -5317,12 +5355,36 @@
           <a:chExt cx="0" cy="0"/>
         </a:xfrm>
       </p:grpSpPr>
-      <p:sp>
-        <p:nvSpPr>
-          <p:cNvPr id="2" name="Text 0"/>
+      <p:pic>
+        <p:nvPicPr>
+          <p:cNvPr id="2" name="Image 0" descr="Asraf JS logo">    </p:cNvPr>
+          <p:cNvPicPr>
+            <a:picLocks noChangeAspect="1"/>
+          </p:cNvPicPr>
+          <p:nvPr/>
+        </p:nvPicPr>
+        <p:blipFill>
+          <a:blip r:embed="rId1"/>
+          <a:stretch>
+            <a:fillRect/>
+          </a:stretch>
+        </p:blipFill>
+        <p:spPr>
+          <a:xfrm>
+            <a:off x="685800" y="5989320"/>
+            <a:ext cx="502920" cy="502920"/>
+          </a:xfrm>
+          <a:prstGeom prst="rect">
+            <a:avLst/>
+          </a:prstGeom>
+        </p:spPr>
+      </p:pic>
+      <p:sp>
+        <p:nvSpPr>
+          <p:cNvPr id="3" name="Text 0"/>
           <p:cNvSpPr/>
           <p:nvPr>
-            <p:ph idx="100" type="body" hasCustomPrompt="1"/>
+            <p:ph idx="101" type="body" hasCustomPrompt="1"/>
           </p:nvPr>
         </p:nvSpPr>
         <p:spPr>
@@ -5343,7 +5405,7 @@
               <a:buNone/>
               <a:defRPr lang="en-US" sz="8800" dirty="0">
                 <a:solidFill>
-                  <a:schemeClr val="bg1"/>
+                  <a:srgbClr val="00EEFC"/>
                 </a:solidFill>
                 <a:latin typeface="Segoe UI Light" pitchFamily="34" charset="0"/>
                 <a:ea typeface="Segoe UI Light" pitchFamily="34" charset="-122"/>
@@ -5361,10 +5423,10 @@
       </p:sp>
       <p:sp>
         <p:nvSpPr>
-          <p:cNvPr id="3" name="Text 0"/>
+          <p:cNvPr id="4" name="Text 0"/>
           <p:cNvSpPr/>
           <p:nvPr>
-            <p:ph idx="101" type="title" hasCustomPrompt="1"/>
+            <p:ph idx="102" type="title" hasCustomPrompt="1"/>
           </p:nvPr>
         </p:nvSpPr>
         <p:spPr>
@@ -5400,16 +5462,16 @@
       </p:sp>
       <p:sp>
         <p:nvSpPr>
-          <p:cNvPr id="4" name="Text 0"/>
+          <p:cNvPr id="5" name="Text 0"/>
           <p:cNvSpPr/>
           <p:nvPr>
-            <p:ph idx="102" type="body" hasCustomPrompt="1"/>
+            <p:ph idx="103" type="body" hasCustomPrompt="1"/>
           </p:nvPr>
         </p:nvSpPr>
         <p:spPr>
           <a:xfrm>
             <a:off x="731520" y="3931920"/>
-            <a:ext cx="9144000" cy="1463040"/>
+            <a:ext cx="6949440" cy="1463040"/>
           </a:xfrm>
           <a:prstGeom prst="rect">
             <a:avLst/>
@@ -5495,9 +5557,16 @@
   <p:cSld name="Content">
     <p:bg>
       <p:bgPr>
-        <a:solidFill>
-          <a:schemeClr val="bg1"/>
-        </a:solidFill>
+        <a:blipFill dpi="0" rotWithShape="1">
+          <a:blip r:embed="rId2">
+            <a:lum/>
+          </a:blip>
+          <a:srcRect/>
+          <a:stretch>
+            <a:fillRect/>
+          </a:stretch>
+        </a:blipFill>
+        <a:effectLst/>
       </p:bgPr>
     </p:bg>
     <p:spTree>
@@ -5592,15 +5661,39 @@
           </a:p>
         </p:txBody>
       </p:sp>
-      <p:sp>
-        <p:nvSpPr>
-          <p:cNvPr id="4" name="Text 0"/>
+      <p:pic>
+        <p:nvPicPr>
+          <p:cNvPr id="4" name="Image 0" descr="Asraf JS logo">    </p:cNvPr>
+          <p:cNvPicPr>
+            <a:picLocks noChangeAspect="1"/>
+          </p:cNvPicPr>
+          <p:nvPr/>
+        </p:nvPicPr>
+        <p:blipFill>
+          <a:blip r:embed="rId1"/>
+          <a:stretch>
+            <a:fillRect/>
+          </a:stretch>
+        </p:blipFill>
+        <p:spPr>
+          <a:xfrm>
+            <a:off x="502920" y="6245352"/>
+            <a:ext cx="384048" cy="384048"/>
+          </a:xfrm>
+          <a:prstGeom prst="rect">
+            <a:avLst/>
+          </a:prstGeom>
+        </p:spPr>
+      </p:pic>
+      <p:sp>
+        <p:nvSpPr>
+          <p:cNvPr id="5" name="Text 0"/>
           <p:cNvSpPr/>
           <p:nvPr/>
         </p:nvSpPr>
         <p:spPr>
           <a:xfrm>
-            <a:off x="548640" y="6355080"/>
+            <a:off x="960120" y="6355080"/>
             <a:ext cx="5486400" cy="274320"/>
           </a:xfrm>
           <a:prstGeom prst="rect">
@@ -5686,9 +5779,16 @@
   <p:cSld name="Statement">
     <p:bg>
       <p:bgPr>
-        <a:solidFill>
-          <a:schemeClr val="bg1"/>
-        </a:solidFill>
+        <a:blipFill dpi="0" rotWithShape="1">
+          <a:blip r:embed="rId2">
+            <a:lum/>
+          </a:blip>
+          <a:srcRect/>
+          <a:stretch>
+            <a:fillRect/>
+          </a:stretch>
+        </a:blipFill>
+        <a:effectLst/>
       </p:bgPr>
     </p:bg>
     <p:spTree>
@@ -5705,12 +5805,36 @@
           <a:chExt cx="0" cy="0"/>
         </a:xfrm>
       </p:grpSpPr>
-      <p:sp>
-        <p:nvSpPr>
-          <p:cNvPr id="2" name="Text 0"/>
+      <p:pic>
+        <p:nvPicPr>
+          <p:cNvPr id="2" name="Image 0" descr="Asraf JS logo">    </p:cNvPr>
+          <p:cNvPicPr>
+            <a:picLocks noChangeAspect="1"/>
+          </p:cNvPicPr>
+          <p:nvPr/>
+        </p:nvPicPr>
+        <p:blipFill>
+          <a:blip r:embed="rId1"/>
+          <a:stretch>
+            <a:fillRect/>
+          </a:stretch>
+        </p:blipFill>
+        <p:spPr>
+          <a:xfrm>
+            <a:off x="685800" y="502920"/>
+            <a:ext cx="548640" cy="548640"/>
+          </a:xfrm>
+          <a:prstGeom prst="rect">
+            <a:avLst/>
+          </a:prstGeom>
+        </p:spPr>
+      </p:pic>
+      <p:sp>
+        <p:nvSpPr>
+          <p:cNvPr id="3" name="Text 0"/>
           <p:cNvSpPr/>
           <p:nvPr>
-            <p:ph idx="100" type="title" hasCustomPrompt="1"/>
+            <p:ph idx="101" type="title" hasCustomPrompt="1"/>
           </p:nvPr>
         </p:nvSpPr>
         <p:spPr>
@@ -5746,10 +5870,10 @@
       </p:sp>
       <p:sp>
         <p:nvSpPr>
-          <p:cNvPr id="3" name="Text 0"/>
+          <p:cNvPr id="4" name="Text 0"/>
           <p:cNvSpPr/>
           <p:nvPr>
-            <p:ph idx="101" type="body" hasCustomPrompt="1"/>
+            <p:ph idx="102" type="body" hasCustomPrompt="1"/>
           </p:nvPr>
         </p:nvSpPr>
         <p:spPr>
@@ -6184,7 +6308,7 @@
           <p:cNvPr id="2" name="Text 0"/>
           <p:cNvSpPr/>
           <p:nvPr>
-            <p:ph idx="100" type="body" hasCustomPrompt="1"/>
+            <p:ph idx="101" type="body" hasCustomPrompt="1"/>
           </p:nvPr>
         </p:nvSpPr>
         <p:spPr>
@@ -6208,7 +6332,7 @@
             <a:r>
               <a:rPr lang="en-US" sz="1600" dirty="0">
                 <a:solidFill>
-                  <a:schemeClr val="bg2"/>
+                  <a:srgbClr val="00EEFC"/>
                 </a:solidFill>
               </a:rPr>
               <a:t>One-day workshop</a:t>
@@ -6222,7 +6346,7 @@
           <p:cNvPr id="3" name="Text 0"/>
           <p:cNvSpPr/>
           <p:nvPr>
-            <p:ph idx="101" type="title" hasCustomPrompt="1"/>
+            <p:ph idx="102" type="title" hasCustomPrompt="1"/>
           </p:nvPr>
         </p:nvSpPr>
         <p:spPr>
@@ -6260,7 +6384,7 @@
           <p:cNvPr id="4" name="Text 0"/>
           <p:cNvSpPr/>
           <p:nvPr>
-            <p:ph idx="102" type="body" hasCustomPrompt="1"/>
+            <p:ph idx="103" type="body" hasCustomPrompt="1"/>
           </p:nvPr>
         </p:nvSpPr>
         <p:spPr>
@@ -6298,7 +6422,7 @@
           <p:cNvPr id="5" name="Text 0"/>
           <p:cNvSpPr/>
           <p:nvPr>
-            <p:ph idx="103" type="body" hasCustomPrompt="1"/>
+            <p:ph idx="104" type="body" hasCustomPrompt="1"/>
           </p:nvPr>
         </p:nvSpPr>
         <p:spPr>
@@ -7651,13 +7775,22 @@
             <a:off x="7589520" y="1783080"/>
             <a:ext cx="4050792" cy="4160520"/>
           </a:xfrm>
-          <a:prstGeom prst="rect">
-            <a:avLst/>
+          <a:prstGeom prst="roundRect">
+            <a:avLst>
+              <a:gd name="adj" fmla="val 2257"/>
+            </a:avLst>
           </a:prstGeom>
           <a:solidFill>
-            <a:schemeClr val="bg2"/>
+            <a:schemeClr val="bg1"/>
           </a:solidFill>
           <a:ln/>
+          <a:effectLst>
+            <a:outerShdw sx="100000" sy="100000" kx="0" ky="0" algn="bl" rotWithShape="0" blurRad="177800" dist="38100" dir="5400000">
+              <a:srgbClr val="1B2A4A">
+                <a:alpha val="12000"/>
+              </a:srgbClr>
+            </a:outerShdw>
+          </a:effectLst>
         </p:spPr>
       </p:sp>
       <p:pic>
@@ -7907,7 +8040,7 @@
           <p:cNvPr id="2" name="Text 0"/>
           <p:cNvSpPr/>
           <p:nvPr>
-            <p:ph idx="100" type="body" hasCustomPrompt="1"/>
+            <p:ph idx="101" type="body" hasCustomPrompt="1"/>
           </p:nvPr>
         </p:nvSpPr>
         <p:spPr>
@@ -7931,7 +8064,7 @@
             <a:r>
               <a:rPr lang="en-US" sz="8800" dirty="0">
                 <a:solidFill>
-                  <a:schemeClr val="bg1"/>
+                  <a:srgbClr val="00EEFC"/>
                 </a:solidFill>
                 <a:latin typeface="Segoe UI Light" pitchFamily="34" charset="0"/>
                 <a:ea typeface="Segoe UI Light" pitchFamily="34" charset="-122"/>
@@ -7948,7 +8081,7 @@
           <p:cNvPr id="3" name="Text 0"/>
           <p:cNvSpPr/>
           <p:nvPr>
-            <p:ph idx="101" type="title" hasCustomPrompt="1"/>
+            <p:ph idx="102" type="title" hasCustomPrompt="1"/>
           </p:nvPr>
         </p:nvSpPr>
         <p:spPr>
@@ -7986,13 +8119,13 @@
           <p:cNvPr id="4" name="Text 0"/>
           <p:cNvSpPr/>
           <p:nvPr>
-            <p:ph idx="102" type="body" hasCustomPrompt="1"/>
+            <p:ph idx="103" type="body" hasCustomPrompt="1"/>
           </p:nvPr>
         </p:nvSpPr>
         <p:spPr>
           <a:xfrm>
             <a:off x="731520" y="3931920"/>
-            <a:ext cx="9144000" cy="1463040"/>
+            <a:ext cx="6949440" cy="1463040"/>
           </a:xfrm>
           <a:prstGeom prst="rect">
             <a:avLst/>
@@ -8740,7 +8873,7 @@
       </p:sp>
       <p:pic>
         <p:nvPicPr>
-          <p:cNvPr id="5" name="Image 0" descr="The message box with the add button and Send highlighted, and Auto in the top bar">    </p:cNvPr>
+          <p:cNvPr id="5" name="Image 0" descr="_design/deck/bg/panel.jpg">    </p:cNvPr>
           <p:cNvPicPr>
             <a:picLocks noChangeAspect="1"/>
           </p:cNvPicPr>
@@ -8748,9 +8881,8 @@
         </p:nvPicPr>
         <p:blipFill>
           <a:blip r:embed="rId1"/>
-          <a:stretch>
-            <a:fillRect/>
-          </a:stretch>
+          <a:srcRect l="0" r="0" t="0" b="0"/>
+          <a:stretch/>
         </p:blipFill>
         <p:spPr>
           <a:xfrm>
@@ -8764,29 +8896,63 @@
       </p:pic>
       <p:sp>
         <p:nvSpPr>
-          <p:cNvPr id="6" name="Screenshot border"/>
+          <p:cNvPr id="6" name="Screenshot frame"/>
           <p:cNvSpPr/>
           <p:nvPr/>
         </p:nvSpPr>
         <p:spPr>
           <a:xfrm>
-            <a:off x="548640" y="1783080"/>
-            <a:ext cx="6949440" cy="3909060"/>
-          </a:xfrm>
-          <a:prstGeom prst="rect">
-            <a:avLst/>
-          </a:prstGeom>
-          <a:ln w="12700">
+            <a:off x="804672" y="1927098"/>
+            <a:ext cx="6437376" cy="3621024"/>
+          </a:xfrm>
+          <a:prstGeom prst="rect">
+            <a:avLst/>
+          </a:prstGeom>
+          <a:solidFill>
+            <a:schemeClr val="bg1"/>
+          </a:solidFill>
+          <a:ln w="9525">
             <a:solidFill>
               <a:srgbClr val="E0E0E0"/>
             </a:solidFill>
             <a:prstDash val="solid"/>
           </a:ln>
-        </p:spPr>
-      </p:sp>
-      <p:sp>
-        <p:nvSpPr>
-          <p:cNvPr id="7" name="Text 3"/>
+          <a:effectLst>
+            <a:outerShdw sx="100000" sy="100000" kx="0" ky="0" algn="bl" rotWithShape="0" blurRad="203200" dist="50800" dir="5400000">
+              <a:srgbClr val="1B2A4A">
+                <a:alpha val="25000"/>
+              </a:srgbClr>
+            </a:outerShdw>
+          </a:effectLst>
+        </p:spPr>
+      </p:sp>
+      <p:pic>
+        <p:nvPicPr>
+          <p:cNvPr id="7" name="Image 1" descr="The message box with the add button and Send highlighted, and Auto in the top bar">    </p:cNvPr>
+          <p:cNvPicPr>
+            <a:picLocks noChangeAspect="1"/>
+          </p:cNvPicPr>
+          <p:nvPr/>
+        </p:nvPicPr>
+        <p:blipFill>
+          <a:blip r:embed="rId2"/>
+          <a:stretch>
+            <a:fillRect/>
+          </a:stretch>
+        </p:blipFill>
+        <p:spPr>
+          <a:xfrm>
+            <a:off x="804672" y="1927098"/>
+            <a:ext cx="6437376" cy="3621024"/>
+          </a:xfrm>
+          <a:prstGeom prst="rect">
+            <a:avLst/>
+          </a:prstGeom>
+        </p:spPr>
+      </p:pic>
+      <p:sp>
+        <p:nvSpPr>
+          <p:cNvPr id="8" name="Text 3"/>
           <p:cNvSpPr txBox="1"/>
           <p:nvPr/>
         </p:nvSpPr>
@@ -8839,7 +9005,7 @@
       </p:sp>
       <p:sp>
         <p:nvSpPr>
-          <p:cNvPr id="8" name="Text 4"/>
+          <p:cNvPr id="9" name="Text 4"/>
           <p:cNvSpPr txBox="1"/>
           <p:nvPr/>
         </p:nvSpPr>
@@ -8892,7 +9058,7 @@
       </p:sp>
       <p:sp>
         <p:nvSpPr>
-          <p:cNvPr id="9" name="Text 5"/>
+          <p:cNvPr id="10" name="Text 5"/>
           <p:cNvSpPr txBox="1"/>
           <p:nvPr/>
         </p:nvSpPr>
@@ -8945,7 +9111,7 @@
       </p:sp>
       <p:sp>
         <p:nvSpPr>
-          <p:cNvPr id="10" name="Text 6"/>
+          <p:cNvPr id="11" name="Text 6"/>
           <p:cNvSpPr txBox="1"/>
           <p:nvPr/>
         </p:nvSpPr>
@@ -8998,7 +9164,7 @@
       </p:sp>
       <p:sp>
         <p:nvSpPr>
-          <p:cNvPr id="11" name="Text 7"/>
+          <p:cNvPr id="12" name="Text 7"/>
           <p:cNvSpPr txBox="1"/>
           <p:nvPr/>
         </p:nvSpPr>
@@ -9581,13 +9747,22 @@
             <a:off x="7589520" y="1783080"/>
             <a:ext cx="4050792" cy="4160520"/>
           </a:xfrm>
-          <a:prstGeom prst="rect">
-            <a:avLst/>
+          <a:prstGeom prst="roundRect">
+            <a:avLst>
+              <a:gd name="adj" fmla="val 2257"/>
+            </a:avLst>
           </a:prstGeom>
           <a:solidFill>
-            <a:schemeClr val="bg2"/>
+            <a:schemeClr val="bg1"/>
           </a:solidFill>
           <a:ln/>
+          <a:effectLst>
+            <a:outerShdw sx="100000" sy="100000" kx="0" ky="0" algn="bl" rotWithShape="0" blurRad="177800" dist="38100" dir="5400000">
+              <a:srgbClr val="1B2A4A">
+                <a:alpha val="12000"/>
+              </a:srgbClr>
+            </a:outerShdw>
+          </a:effectLst>
         </p:spPr>
       </p:sp>
       <p:pic>
@@ -9837,7 +10012,7 @@
           <p:cNvPr id="2" name="Text 0"/>
           <p:cNvSpPr/>
           <p:nvPr>
-            <p:ph idx="100" type="body" hasCustomPrompt="1"/>
+            <p:ph idx="101" type="body" hasCustomPrompt="1"/>
           </p:nvPr>
         </p:nvSpPr>
         <p:spPr>
@@ -9861,7 +10036,7 @@
             <a:r>
               <a:rPr lang="en-US" sz="8800" dirty="0">
                 <a:solidFill>
-                  <a:schemeClr val="bg1"/>
+                  <a:srgbClr val="00EEFC"/>
                 </a:solidFill>
                 <a:latin typeface="Segoe UI Light" pitchFamily="34" charset="0"/>
                 <a:ea typeface="Segoe UI Light" pitchFamily="34" charset="-122"/>
@@ -9878,7 +10053,7 @@
           <p:cNvPr id="3" name="Text 0"/>
           <p:cNvSpPr/>
           <p:nvPr>
-            <p:ph idx="101" type="title" hasCustomPrompt="1"/>
+            <p:ph idx="102" type="title" hasCustomPrompt="1"/>
           </p:nvPr>
         </p:nvSpPr>
         <p:spPr>
@@ -9916,13 +10091,13 @@
           <p:cNvPr id="4" name="Text 0"/>
           <p:cNvSpPr/>
           <p:nvPr>
-            <p:ph idx="102" type="body" hasCustomPrompt="1"/>
+            <p:ph idx="103" type="body" hasCustomPrompt="1"/>
           </p:nvPr>
         </p:nvSpPr>
         <p:spPr>
           <a:xfrm>
             <a:off x="731520" y="3931920"/>
-            <a:ext cx="9144000" cy="1463040"/>
+            <a:ext cx="6949440" cy="1463040"/>
           </a:xfrm>
           <a:prstGeom prst="rect">
             <a:avLst/>
@@ -10893,7 +11068,7 @@
           <p:cNvPr id="2" name="Text 0"/>
           <p:cNvSpPr/>
           <p:nvPr>
-            <p:ph idx="100" type="title" hasCustomPrompt="1"/>
+            <p:ph idx="101" type="title" hasCustomPrompt="1"/>
           </p:nvPr>
         </p:nvSpPr>
         <p:spPr>
@@ -10931,7 +11106,7 @@
           <p:cNvPr id="3" name="Text 0"/>
           <p:cNvSpPr/>
           <p:nvPr>
-            <p:ph idx="101" type="body" hasCustomPrompt="1"/>
+            <p:ph idx="102" type="body" hasCustomPrompt="1"/>
           </p:nvPr>
         </p:nvSpPr>
         <p:spPr>
@@ -11681,8 +11856,10 @@
             <a:off x="548640" y="1783080"/>
             <a:ext cx="6035040" cy="4160520"/>
           </a:xfrm>
-          <a:prstGeom prst="rect">
-            <a:avLst/>
+          <a:prstGeom prst="roundRect">
+            <a:avLst>
+              <a:gd name="adj" fmla="val 2198"/>
+            </a:avLst>
           </a:prstGeom>
           <a:solidFill>
             <a:schemeClr val="tx2"/>
@@ -12584,13 +12761,22 @@
             <a:off x="7589520" y="1783080"/>
             <a:ext cx="4050792" cy="4160520"/>
           </a:xfrm>
-          <a:prstGeom prst="rect">
-            <a:avLst/>
+          <a:prstGeom prst="roundRect">
+            <a:avLst>
+              <a:gd name="adj" fmla="val 2257"/>
+            </a:avLst>
           </a:prstGeom>
           <a:solidFill>
-            <a:schemeClr val="bg2"/>
+            <a:schemeClr val="bg1"/>
           </a:solidFill>
           <a:ln/>
+          <a:effectLst>
+            <a:outerShdw sx="100000" sy="100000" kx="0" ky="0" algn="bl" rotWithShape="0" blurRad="177800" dist="38100" dir="5400000">
+              <a:srgbClr val="1B2A4A">
+                <a:alpha val="12000"/>
+              </a:srgbClr>
+            </a:outerShdw>
+          </a:effectLst>
         </p:spPr>
       </p:sp>
       <p:pic>
@@ -12840,7 +13026,7 @@
           <p:cNvPr id="2" name="Text 0"/>
           <p:cNvSpPr/>
           <p:nvPr>
-            <p:ph idx="100" type="body" hasCustomPrompt="1"/>
+            <p:ph idx="101" type="body" hasCustomPrompt="1"/>
           </p:nvPr>
         </p:nvSpPr>
         <p:spPr>
@@ -12864,7 +13050,7 @@
             <a:r>
               <a:rPr lang="en-US" sz="8800" dirty="0">
                 <a:solidFill>
-                  <a:schemeClr val="bg1"/>
+                  <a:srgbClr val="00EEFC"/>
                 </a:solidFill>
                 <a:latin typeface="Segoe UI Light" pitchFamily="34" charset="0"/>
                 <a:ea typeface="Segoe UI Light" pitchFamily="34" charset="-122"/>
@@ -12881,7 +13067,7 @@
           <p:cNvPr id="3" name="Text 0"/>
           <p:cNvSpPr/>
           <p:nvPr>
-            <p:ph idx="101" type="title" hasCustomPrompt="1"/>
+            <p:ph idx="102" type="title" hasCustomPrompt="1"/>
           </p:nvPr>
         </p:nvSpPr>
         <p:spPr>
@@ -12919,13 +13105,13 @@
           <p:cNvPr id="4" name="Text 0"/>
           <p:cNvSpPr/>
           <p:nvPr>
-            <p:ph idx="102" type="body" hasCustomPrompt="1"/>
+            <p:ph idx="103" type="body" hasCustomPrompt="1"/>
           </p:nvPr>
         </p:nvSpPr>
         <p:spPr>
           <a:xfrm>
             <a:off x="731520" y="3931920"/>
-            <a:ext cx="9144000" cy="1463040"/>
+            <a:ext cx="6949440" cy="1463040"/>
           </a:xfrm>
           <a:prstGeom prst="rect">
             <a:avLst/>
@@ -13536,13 +13722,22 @@
             <a:off x="548640" y="4206240"/>
             <a:ext cx="11064240" cy="1737360"/>
           </a:xfrm>
-          <a:prstGeom prst="rect">
-            <a:avLst/>
+          <a:prstGeom prst="roundRect">
+            <a:avLst>
+              <a:gd name="adj" fmla="val 5263"/>
+            </a:avLst>
           </a:prstGeom>
           <a:solidFill>
-            <a:schemeClr val="bg2"/>
+            <a:schemeClr val="bg1"/>
           </a:solidFill>
           <a:ln/>
+          <a:effectLst>
+            <a:outerShdw sx="100000" sy="100000" kx="0" ky="0" algn="bl" rotWithShape="0" blurRad="177800" dist="38100" dir="5400000">
+              <a:srgbClr val="1B2A4A">
+                <a:alpha val="12000"/>
+              </a:srgbClr>
+            </a:outerShdw>
+          </a:effectLst>
         </p:spPr>
       </p:sp>
       <p:pic>
@@ -13785,7 +13980,7 @@
           <a:noFill/>
           <a:ln w="25400">
             <a:solidFill>
-              <a:srgbClr val="0078D4"/>
+              <a:srgbClr val="6B5DD3"/>
             </a:solidFill>
             <a:prstDash val="solid"/>
           </a:ln>
@@ -14709,7 +14904,7 @@
           <p:cNvPr id="2" name="Text 0"/>
           <p:cNvSpPr/>
           <p:nvPr>
-            <p:ph idx="100" type="title" hasCustomPrompt="1"/>
+            <p:ph idx="101" type="title" hasCustomPrompt="1"/>
           </p:nvPr>
         </p:nvSpPr>
         <p:spPr>
@@ -14747,7 +14942,7 @@
           <p:cNvPr id="3" name="Text 0"/>
           <p:cNvSpPr/>
           <p:nvPr>
-            <p:ph idx="101" type="body" hasCustomPrompt="1"/>
+            <p:ph idx="102" type="body" hasCustomPrompt="1"/>
           </p:nvPr>
         </p:nvSpPr>
         <p:spPr>
@@ -15537,13 +15732,22 @@
             <a:off x="7589520" y="1783080"/>
             <a:ext cx="4050792" cy="4160520"/>
           </a:xfrm>
-          <a:prstGeom prst="rect">
-            <a:avLst/>
+          <a:prstGeom prst="roundRect">
+            <a:avLst>
+              <a:gd name="adj" fmla="val 2257"/>
+            </a:avLst>
           </a:prstGeom>
           <a:solidFill>
-            <a:schemeClr val="bg2"/>
+            <a:schemeClr val="bg1"/>
           </a:solidFill>
           <a:ln/>
+          <a:effectLst>
+            <a:outerShdw sx="100000" sy="100000" kx="0" ky="0" algn="bl" rotWithShape="0" blurRad="177800" dist="38100" dir="5400000">
+              <a:srgbClr val="1B2A4A">
+                <a:alpha val="12000"/>
+              </a:srgbClr>
+            </a:outerShdw>
+          </a:effectLst>
         </p:spPr>
       </p:sp>
       <p:pic>
@@ -16172,8 +16376,10 @@
             <a:off x="548640" y="4572000"/>
             <a:ext cx="11064240" cy="1371600"/>
           </a:xfrm>
-          <a:prstGeom prst="rect">
-            <a:avLst/>
+          <a:prstGeom prst="roundRect">
+            <a:avLst>
+              <a:gd name="adj" fmla="val 6667"/>
+            </a:avLst>
           </a:prstGeom>
           <a:solidFill>
             <a:schemeClr val="tx2"/>
@@ -16295,7 +16501,7 @@
           <p:cNvPr id="2" name="Text 0"/>
           <p:cNvSpPr/>
           <p:nvPr>
-            <p:ph idx="100" type="body" hasCustomPrompt="1"/>
+            <p:ph idx="101" type="body" hasCustomPrompt="1"/>
           </p:nvPr>
         </p:nvSpPr>
         <p:spPr>
@@ -16319,7 +16525,7 @@
             <a:r>
               <a:rPr lang="en-US" sz="8800" dirty="0">
                 <a:solidFill>
-                  <a:schemeClr val="bg1"/>
+                  <a:srgbClr val="00EEFC"/>
                 </a:solidFill>
                 <a:latin typeface="Segoe UI Light" pitchFamily="34" charset="0"/>
                 <a:ea typeface="Segoe UI Light" pitchFamily="34" charset="-122"/>
@@ -16336,7 +16542,7 @@
           <p:cNvPr id="3" name="Text 0"/>
           <p:cNvSpPr/>
           <p:nvPr>
-            <p:ph idx="101" type="title" hasCustomPrompt="1"/>
+            <p:ph idx="102" type="title" hasCustomPrompt="1"/>
           </p:nvPr>
         </p:nvSpPr>
         <p:spPr>
@@ -16374,13 +16580,13 @@
           <p:cNvPr id="4" name="Text 0"/>
           <p:cNvSpPr/>
           <p:nvPr>
-            <p:ph idx="102" type="body" hasCustomPrompt="1"/>
+            <p:ph idx="103" type="body" hasCustomPrompt="1"/>
           </p:nvPr>
         </p:nvSpPr>
         <p:spPr>
           <a:xfrm>
             <a:off x="731520" y="3931920"/>
-            <a:ext cx="9144000" cy="1463040"/>
+            <a:ext cx="6949440" cy="1463040"/>
           </a:xfrm>
           <a:prstGeom prst="rect">
             <a:avLst/>
@@ -16586,7 +16792,7 @@
       </p:sp>
       <p:pic>
         <p:nvPicPr>
-          <p:cNvPr id="5" name="Image 0" descr="Outlook on the web with Summarize this email and the Copilot pane showing a thread summary">    </p:cNvPr>
+          <p:cNvPr id="5" name="Image 0" descr="_design/deck/bg/panel.jpg">    </p:cNvPr>
           <p:cNvPicPr>
             <a:picLocks noChangeAspect="1"/>
           </p:cNvPicPr>
@@ -16594,9 +16800,8 @@
         </p:nvPicPr>
         <p:blipFill>
           <a:blip r:embed="rId1"/>
-          <a:stretch>
-            <a:fillRect/>
-          </a:stretch>
+          <a:srcRect l="0" r="0" t="0" b="0"/>
+          <a:stretch/>
         </p:blipFill>
         <p:spPr>
           <a:xfrm>
@@ -16610,29 +16815,63 @@
       </p:pic>
       <p:sp>
         <p:nvSpPr>
-          <p:cNvPr id="6" name="Screenshot border"/>
+          <p:cNvPr id="6" name="Screenshot frame"/>
           <p:cNvSpPr/>
           <p:nvPr/>
         </p:nvSpPr>
         <p:spPr>
           <a:xfrm>
-            <a:off x="548640" y="1783080"/>
-            <a:ext cx="6949440" cy="3909060"/>
-          </a:xfrm>
-          <a:prstGeom prst="rect">
-            <a:avLst/>
-          </a:prstGeom>
-          <a:ln w="12700">
+            <a:off x="804672" y="1927098"/>
+            <a:ext cx="6437376" cy="3621024"/>
+          </a:xfrm>
+          <a:prstGeom prst="rect">
+            <a:avLst/>
+          </a:prstGeom>
+          <a:solidFill>
+            <a:schemeClr val="bg1"/>
+          </a:solidFill>
+          <a:ln w="9525">
             <a:solidFill>
               <a:srgbClr val="E0E0E0"/>
             </a:solidFill>
             <a:prstDash val="solid"/>
           </a:ln>
-        </p:spPr>
-      </p:sp>
-      <p:sp>
-        <p:nvSpPr>
-          <p:cNvPr id="7" name="Text 3"/>
+          <a:effectLst>
+            <a:outerShdw sx="100000" sy="100000" kx="0" ky="0" algn="bl" rotWithShape="0" blurRad="203200" dist="50800" dir="5400000">
+              <a:srgbClr val="1B2A4A">
+                <a:alpha val="25000"/>
+              </a:srgbClr>
+            </a:outerShdw>
+          </a:effectLst>
+        </p:spPr>
+      </p:sp>
+      <p:pic>
+        <p:nvPicPr>
+          <p:cNvPr id="7" name="Image 1" descr="Outlook on the web with Summarize this email and the Copilot pane showing a thread summary">    </p:cNvPr>
+          <p:cNvPicPr>
+            <a:picLocks noChangeAspect="1"/>
+          </p:cNvPicPr>
+          <p:nvPr/>
+        </p:nvPicPr>
+        <p:blipFill>
+          <a:blip r:embed="rId2"/>
+          <a:stretch>
+            <a:fillRect/>
+          </a:stretch>
+        </p:blipFill>
+        <p:spPr>
+          <a:xfrm>
+            <a:off x="804672" y="1927098"/>
+            <a:ext cx="6437376" cy="3621024"/>
+          </a:xfrm>
+          <a:prstGeom prst="rect">
+            <a:avLst/>
+          </a:prstGeom>
+        </p:spPr>
+      </p:pic>
+      <p:sp>
+        <p:nvSpPr>
+          <p:cNvPr id="8" name="Text 3"/>
           <p:cNvSpPr txBox="1"/>
           <p:nvPr/>
         </p:nvSpPr>
@@ -16685,7 +16924,7 @@
       </p:sp>
       <p:sp>
         <p:nvSpPr>
-          <p:cNvPr id="8" name="Text 4"/>
+          <p:cNvPr id="9" name="Text 4"/>
           <p:cNvSpPr txBox="1"/>
           <p:nvPr/>
         </p:nvSpPr>
@@ -16738,7 +16977,7 @@
       </p:sp>
       <p:sp>
         <p:nvSpPr>
-          <p:cNvPr id="9" name="Text 5"/>
+          <p:cNvPr id="10" name="Text 5"/>
           <p:cNvSpPr txBox="1"/>
           <p:nvPr/>
         </p:nvSpPr>
@@ -16791,7 +17030,7 @@
       </p:sp>
       <p:sp>
         <p:nvSpPr>
-          <p:cNvPr id="10" name="Text 6"/>
+          <p:cNvPr id="11" name="Text 6"/>
           <p:cNvSpPr txBox="1"/>
           <p:nvPr/>
         </p:nvSpPr>
@@ -16917,7 +17156,7 @@
           <p:cNvPr id="2" name="Text 0"/>
           <p:cNvSpPr/>
           <p:nvPr>
-            <p:ph idx="100" type="title" hasCustomPrompt="1"/>
+            <p:ph idx="101" type="title" hasCustomPrompt="1"/>
           </p:nvPr>
         </p:nvSpPr>
         <p:spPr>
@@ -16955,7 +17194,7 @@
           <p:cNvPr id="3" name="Text 0"/>
           <p:cNvSpPr/>
           <p:nvPr>
-            <p:ph idx="101" type="body" hasCustomPrompt="1"/>
+            <p:ph idx="102" type="body" hasCustomPrompt="1"/>
           </p:nvPr>
         </p:nvSpPr>
         <p:spPr>
@@ -19036,13 +19275,22 @@
             <a:off x="7589520" y="1783080"/>
             <a:ext cx="4050792" cy="4160520"/>
           </a:xfrm>
-          <a:prstGeom prst="rect">
-            <a:avLst/>
+          <a:prstGeom prst="roundRect">
+            <a:avLst>
+              <a:gd name="adj" fmla="val 2257"/>
+            </a:avLst>
           </a:prstGeom>
           <a:solidFill>
-            <a:schemeClr val="bg2"/>
+            <a:schemeClr val="bg1"/>
           </a:solidFill>
           <a:ln/>
+          <a:effectLst>
+            <a:outerShdw sx="100000" sy="100000" kx="0" ky="0" algn="bl" rotWithShape="0" blurRad="177800" dist="38100" dir="5400000">
+              <a:srgbClr val="1B2A4A">
+                <a:alpha val="12000"/>
+              </a:srgbClr>
+            </a:outerShdw>
+          </a:effectLst>
         </p:spPr>
       </p:sp>
       <p:pic>
@@ -19292,7 +19540,7 @@
           <p:cNvPr id="2" name="Text 0"/>
           <p:cNvSpPr/>
           <p:nvPr>
-            <p:ph idx="100" type="body" hasCustomPrompt="1"/>
+            <p:ph idx="101" type="body" hasCustomPrompt="1"/>
           </p:nvPr>
         </p:nvSpPr>
         <p:spPr>
@@ -19316,7 +19564,7 @@
             <a:r>
               <a:rPr lang="en-US" sz="8800" dirty="0">
                 <a:solidFill>
-                  <a:schemeClr val="bg1"/>
+                  <a:srgbClr val="00EEFC"/>
                 </a:solidFill>
                 <a:latin typeface="Segoe UI Light" pitchFamily="34" charset="0"/>
                 <a:ea typeface="Segoe UI Light" pitchFamily="34" charset="-122"/>
@@ -19333,7 +19581,7 @@
           <p:cNvPr id="3" name="Text 0"/>
           <p:cNvSpPr/>
           <p:nvPr>
-            <p:ph idx="101" type="title" hasCustomPrompt="1"/>
+            <p:ph idx="102" type="title" hasCustomPrompt="1"/>
           </p:nvPr>
         </p:nvSpPr>
         <p:spPr>
@@ -19371,13 +19619,13 @@
           <p:cNvPr id="4" name="Text 0"/>
           <p:cNvSpPr/>
           <p:nvPr>
-            <p:ph idx="102" type="body" hasCustomPrompt="1"/>
+            <p:ph idx="103" type="body" hasCustomPrompt="1"/>
           </p:nvPr>
         </p:nvSpPr>
         <p:spPr>
           <a:xfrm>
             <a:off x="731520" y="3931920"/>
-            <a:ext cx="9144000" cy="1463040"/>
+            <a:ext cx="6949440" cy="1463040"/>
           </a:xfrm>
           <a:prstGeom prst="rect">
             <a:avLst/>
@@ -20892,7 +21140,7 @@
       </p:sp>
       <p:pic>
         <p:nvPicPr>
-          <p:cNvPr id="5" name="Image 0" descr="A Copilot Page with the laptop comparison table, next to the chat">    </p:cNvPr>
+          <p:cNvPr id="5" name="Image 0" descr="_design/deck/bg/panel.jpg">    </p:cNvPr>
           <p:cNvPicPr>
             <a:picLocks noChangeAspect="1"/>
           </p:cNvPicPr>
@@ -20900,9 +21148,8 @@
         </p:nvPicPr>
         <p:blipFill>
           <a:blip r:embed="rId1"/>
-          <a:stretch>
-            <a:fillRect/>
-          </a:stretch>
+          <a:srcRect l="0" r="0" t="0" b="0"/>
+          <a:stretch/>
         </p:blipFill>
         <p:spPr>
           <a:xfrm>
@@ -20916,29 +21163,63 @@
       </p:pic>
       <p:sp>
         <p:nvSpPr>
-          <p:cNvPr id="6" name="Screenshot border"/>
+          <p:cNvPr id="6" name="Screenshot frame"/>
           <p:cNvSpPr/>
           <p:nvPr/>
         </p:nvSpPr>
         <p:spPr>
           <a:xfrm>
-            <a:off x="548640" y="1783080"/>
-            <a:ext cx="6949440" cy="3909060"/>
-          </a:xfrm>
-          <a:prstGeom prst="rect">
-            <a:avLst/>
-          </a:prstGeom>
-          <a:ln w="12700">
+            <a:off x="804672" y="1927098"/>
+            <a:ext cx="6437376" cy="3621024"/>
+          </a:xfrm>
+          <a:prstGeom prst="rect">
+            <a:avLst/>
+          </a:prstGeom>
+          <a:solidFill>
+            <a:schemeClr val="bg1"/>
+          </a:solidFill>
+          <a:ln w="9525">
             <a:solidFill>
               <a:srgbClr val="E0E0E0"/>
             </a:solidFill>
             <a:prstDash val="solid"/>
           </a:ln>
-        </p:spPr>
-      </p:sp>
-      <p:sp>
-        <p:nvSpPr>
-          <p:cNvPr id="7" name="Text 3"/>
+          <a:effectLst>
+            <a:outerShdw sx="100000" sy="100000" kx="0" ky="0" algn="bl" rotWithShape="0" blurRad="203200" dist="50800" dir="5400000">
+              <a:srgbClr val="1B2A4A">
+                <a:alpha val="25000"/>
+              </a:srgbClr>
+            </a:outerShdw>
+          </a:effectLst>
+        </p:spPr>
+      </p:sp>
+      <p:pic>
+        <p:nvPicPr>
+          <p:cNvPr id="7" name="Image 1" descr="A Copilot Page with the laptop comparison table, next to the chat">    </p:cNvPr>
+          <p:cNvPicPr>
+            <a:picLocks noChangeAspect="1"/>
+          </p:cNvPicPr>
+          <p:nvPr/>
+        </p:nvPicPr>
+        <p:blipFill>
+          <a:blip r:embed="rId2"/>
+          <a:stretch>
+            <a:fillRect/>
+          </a:stretch>
+        </p:blipFill>
+        <p:spPr>
+          <a:xfrm>
+            <a:off x="804672" y="1927098"/>
+            <a:ext cx="6437376" cy="3621024"/>
+          </a:xfrm>
+          <a:prstGeom prst="rect">
+            <a:avLst/>
+          </a:prstGeom>
+        </p:spPr>
+      </p:pic>
+      <p:sp>
+        <p:nvSpPr>
+          <p:cNvPr id="8" name="Text 3"/>
           <p:cNvSpPr txBox="1"/>
           <p:nvPr/>
         </p:nvSpPr>
@@ -20977,7 +21258,7 @@
       </p:sp>
       <p:sp>
         <p:nvSpPr>
-          <p:cNvPr id="8" name="Text 4"/>
+          <p:cNvPr id="9" name="Text 4"/>
           <p:cNvSpPr txBox="1"/>
           <p:nvPr/>
         </p:nvSpPr>
@@ -21030,7 +21311,7 @@
       </p:sp>
       <p:sp>
         <p:nvSpPr>
-          <p:cNvPr id="9" name="Text 5"/>
+          <p:cNvPr id="10" name="Text 5"/>
           <p:cNvSpPr txBox="1"/>
           <p:nvPr/>
         </p:nvSpPr>
@@ -21069,7 +21350,7 @@
       </p:sp>
       <p:sp>
         <p:nvSpPr>
-          <p:cNvPr id="10" name="Text 6"/>
+          <p:cNvPr id="11" name="Text 6"/>
           <p:cNvSpPr txBox="1"/>
           <p:nvPr/>
         </p:nvSpPr>
@@ -21122,7 +21403,7 @@
       </p:sp>
       <p:sp>
         <p:nvSpPr>
-          <p:cNvPr id="11" name="Text 7"/>
+          <p:cNvPr id="12" name="Text 7"/>
           <p:cNvSpPr txBox="1"/>
           <p:nvPr/>
         </p:nvSpPr>
@@ -21161,7 +21442,7 @@
       </p:sp>
       <p:sp>
         <p:nvSpPr>
-          <p:cNvPr id="12" name="Text 8"/>
+          <p:cNvPr id="13" name="Text 8"/>
           <p:cNvSpPr txBox="1"/>
           <p:nvPr/>
         </p:nvSpPr>
@@ -21214,7 +21495,7 @@
       </p:sp>
       <p:sp>
         <p:nvSpPr>
-          <p:cNvPr id="13" name="Text 9"/>
+          <p:cNvPr id="14" name="Text 9"/>
           <p:cNvSpPr txBox="1"/>
           <p:nvPr/>
         </p:nvSpPr>
@@ -21253,7 +21534,7 @@
       </p:sp>
       <p:sp>
         <p:nvSpPr>
-          <p:cNvPr id="14" name="Text 10"/>
+          <p:cNvPr id="15" name="Text 10"/>
           <p:cNvSpPr txBox="1"/>
           <p:nvPr/>
         </p:nvSpPr>
@@ -21911,13 +22192,22 @@
             <a:off x="7589520" y="1783080"/>
             <a:ext cx="4050792" cy="4160520"/>
           </a:xfrm>
-          <a:prstGeom prst="rect">
-            <a:avLst/>
+          <a:prstGeom prst="roundRect">
+            <a:avLst>
+              <a:gd name="adj" fmla="val 2257"/>
+            </a:avLst>
           </a:prstGeom>
           <a:solidFill>
-            <a:schemeClr val="bg2"/>
+            <a:schemeClr val="bg1"/>
           </a:solidFill>
           <a:ln/>
+          <a:effectLst>
+            <a:outerShdw sx="100000" sy="100000" kx="0" ky="0" algn="bl" rotWithShape="0" blurRad="177800" dist="38100" dir="5400000">
+              <a:srgbClr val="1B2A4A">
+                <a:alpha val="12000"/>
+              </a:srgbClr>
+            </a:outerShdw>
+          </a:effectLst>
         </p:spPr>
       </p:sp>
       <p:pic>
@@ -22167,7 +22457,7 @@
           <p:cNvPr id="2" name="Text 0"/>
           <p:cNvSpPr/>
           <p:nvPr>
-            <p:ph idx="100" type="body" hasCustomPrompt="1"/>
+            <p:ph idx="101" type="body" hasCustomPrompt="1"/>
           </p:nvPr>
         </p:nvSpPr>
         <p:spPr>
@@ -22191,7 +22481,7 @@
             <a:r>
               <a:rPr lang="en-US" sz="8800" dirty="0">
                 <a:solidFill>
-                  <a:schemeClr val="bg1"/>
+                  <a:srgbClr val="00EEFC"/>
                 </a:solidFill>
                 <a:latin typeface="Segoe UI Light" pitchFamily="34" charset="0"/>
                 <a:ea typeface="Segoe UI Light" pitchFamily="34" charset="-122"/>
@@ -22208,7 +22498,7 @@
           <p:cNvPr id="3" name="Text 0"/>
           <p:cNvSpPr/>
           <p:nvPr>
-            <p:ph idx="101" type="title" hasCustomPrompt="1"/>
+            <p:ph idx="102" type="title" hasCustomPrompt="1"/>
           </p:nvPr>
         </p:nvSpPr>
         <p:spPr>
@@ -22246,13 +22536,13 @@
           <p:cNvPr id="4" name="Text 0"/>
           <p:cNvSpPr/>
           <p:nvPr>
-            <p:ph idx="102" type="body" hasCustomPrompt="1"/>
+            <p:ph idx="103" type="body" hasCustomPrompt="1"/>
           </p:nvPr>
         </p:nvSpPr>
         <p:spPr>
           <a:xfrm>
             <a:off x="731520" y="3931920"/>
-            <a:ext cx="9144000" cy="1463040"/>
+            <a:ext cx="6949440" cy="1463040"/>
           </a:xfrm>
           <a:prstGeom prst="rect">
             <a:avLst/>
@@ -22458,7 +22748,7 @@
       </p:sp>
       <p:pic>
         <p:nvPicPr>
-          <p:cNvPr id="5" name="Image 0" descr="A Notebook answering what's outstanding, with the references listed on the right">    </p:cNvPr>
+          <p:cNvPr id="5" name="Image 0" descr="_design/deck/bg/panel.jpg">    </p:cNvPr>
           <p:cNvPicPr>
             <a:picLocks noChangeAspect="1"/>
           </p:cNvPicPr>
@@ -22466,9 +22756,8 @@
         </p:nvPicPr>
         <p:blipFill>
           <a:blip r:embed="rId1"/>
-          <a:stretch>
-            <a:fillRect/>
-          </a:stretch>
+          <a:srcRect l="0" r="0" t="0" b="0"/>
+          <a:stretch/>
         </p:blipFill>
         <p:spPr>
           <a:xfrm>
@@ -22482,29 +22771,63 @@
       </p:pic>
       <p:sp>
         <p:nvSpPr>
-          <p:cNvPr id="6" name="Screenshot border"/>
+          <p:cNvPr id="6" name="Screenshot frame"/>
           <p:cNvSpPr/>
           <p:nvPr/>
         </p:nvSpPr>
         <p:spPr>
           <a:xfrm>
-            <a:off x="548640" y="1783080"/>
-            <a:ext cx="6949440" cy="3909060"/>
-          </a:xfrm>
-          <a:prstGeom prst="rect">
-            <a:avLst/>
-          </a:prstGeom>
-          <a:ln w="12700">
+            <a:off x="804672" y="1927098"/>
+            <a:ext cx="6437376" cy="3621024"/>
+          </a:xfrm>
+          <a:prstGeom prst="rect">
+            <a:avLst/>
+          </a:prstGeom>
+          <a:solidFill>
+            <a:schemeClr val="bg1"/>
+          </a:solidFill>
+          <a:ln w="9525">
             <a:solidFill>
               <a:srgbClr val="E0E0E0"/>
             </a:solidFill>
             <a:prstDash val="solid"/>
           </a:ln>
-        </p:spPr>
-      </p:sp>
-      <p:sp>
-        <p:nvSpPr>
-          <p:cNvPr id="7" name="Text 3"/>
+          <a:effectLst>
+            <a:outerShdw sx="100000" sy="100000" kx="0" ky="0" algn="bl" rotWithShape="0" blurRad="203200" dist="50800" dir="5400000">
+              <a:srgbClr val="1B2A4A">
+                <a:alpha val="25000"/>
+              </a:srgbClr>
+            </a:outerShdw>
+          </a:effectLst>
+        </p:spPr>
+      </p:sp>
+      <p:pic>
+        <p:nvPicPr>
+          <p:cNvPr id="7" name="Image 1" descr="A Notebook answering what's outstanding, with the references listed on the right">    </p:cNvPr>
+          <p:cNvPicPr>
+            <a:picLocks noChangeAspect="1"/>
+          </p:cNvPicPr>
+          <p:nvPr/>
+        </p:nvPicPr>
+        <p:blipFill>
+          <a:blip r:embed="rId2"/>
+          <a:stretch>
+            <a:fillRect/>
+          </a:stretch>
+        </p:blipFill>
+        <p:spPr>
+          <a:xfrm>
+            <a:off x="804672" y="1927098"/>
+            <a:ext cx="6437376" cy="3621024"/>
+          </a:xfrm>
+          <a:prstGeom prst="rect">
+            <a:avLst/>
+          </a:prstGeom>
+        </p:spPr>
+      </p:pic>
+      <p:sp>
+        <p:nvSpPr>
+          <p:cNvPr id="8" name="Text 3"/>
           <p:cNvSpPr txBox="1"/>
           <p:nvPr/>
         </p:nvSpPr>
@@ -22557,7 +22880,7 @@
       </p:sp>
       <p:sp>
         <p:nvSpPr>
-          <p:cNvPr id="8" name="Text 4"/>
+          <p:cNvPr id="9" name="Text 4"/>
           <p:cNvSpPr txBox="1"/>
           <p:nvPr/>
         </p:nvSpPr>
@@ -22610,7 +22933,7 @@
       </p:sp>
       <p:sp>
         <p:nvSpPr>
-          <p:cNvPr id="9" name="Text 5"/>
+          <p:cNvPr id="10" name="Text 5"/>
           <p:cNvSpPr txBox="1"/>
           <p:nvPr/>
         </p:nvSpPr>
@@ -22663,7 +22986,7 @@
       </p:sp>
       <p:sp>
         <p:nvSpPr>
-          <p:cNvPr id="10" name="Text 6"/>
+          <p:cNvPr id="11" name="Text 6"/>
           <p:cNvSpPr txBox="1"/>
           <p:nvPr/>
         </p:nvSpPr>
@@ -23171,13 +23494,22 @@
             <a:off x="7589520" y="1783080"/>
             <a:ext cx="4050792" cy="4160520"/>
           </a:xfrm>
-          <a:prstGeom prst="rect">
-            <a:avLst/>
+          <a:prstGeom prst="roundRect">
+            <a:avLst>
+              <a:gd name="adj" fmla="val 2257"/>
+            </a:avLst>
           </a:prstGeom>
           <a:solidFill>
-            <a:schemeClr val="bg2"/>
+            <a:schemeClr val="bg1"/>
           </a:solidFill>
           <a:ln/>
+          <a:effectLst>
+            <a:outerShdw sx="100000" sy="100000" kx="0" ky="0" algn="bl" rotWithShape="0" blurRad="177800" dist="38100" dir="5400000">
+              <a:srgbClr val="1B2A4A">
+                <a:alpha val="12000"/>
+              </a:srgbClr>
+            </a:outerShdw>
+          </a:effectLst>
         </p:spPr>
       </p:sp>
       <p:pic>
@@ -23427,7 +23759,7 @@
           <p:cNvPr id="2" name="Text 0"/>
           <p:cNvSpPr/>
           <p:nvPr>
-            <p:ph idx="100" type="body" hasCustomPrompt="1"/>
+            <p:ph idx="101" type="body" hasCustomPrompt="1"/>
           </p:nvPr>
         </p:nvSpPr>
         <p:spPr>
@@ -23451,7 +23783,7 @@
             <a:r>
               <a:rPr lang="en-US" sz="8800" dirty="0">
                 <a:solidFill>
-                  <a:schemeClr val="bg1"/>
+                  <a:srgbClr val="00EEFC"/>
                 </a:solidFill>
                 <a:latin typeface="Segoe UI Light" pitchFamily="34" charset="0"/>
                 <a:ea typeface="Segoe UI Light" pitchFamily="34" charset="-122"/>
@@ -23468,7 +23800,7 @@
           <p:cNvPr id="3" name="Text 0"/>
           <p:cNvSpPr/>
           <p:nvPr>
-            <p:ph idx="101" type="title" hasCustomPrompt="1"/>
+            <p:ph idx="102" type="title" hasCustomPrompt="1"/>
           </p:nvPr>
         </p:nvSpPr>
         <p:spPr>
@@ -23506,13 +23838,13 @@
           <p:cNvPr id="4" name="Text 0"/>
           <p:cNvSpPr/>
           <p:nvPr>
-            <p:ph idx="102" type="body" hasCustomPrompt="1"/>
+            <p:ph idx="103" type="body" hasCustomPrompt="1"/>
           </p:nvPr>
         </p:nvSpPr>
         <p:spPr>
           <a:xfrm>
             <a:off x="731520" y="3931920"/>
-            <a:ext cx="9144000" cy="1463040"/>
+            <a:ext cx="6949440" cy="1463040"/>
           </a:xfrm>
           <a:prstGeom prst="rect">
             <a:avLst/>
@@ -25945,7 +26277,7 @@
       </p:sp>
       <p:pic>
         <p:nvPicPr>
-          <p:cNvPr id="5" name="Image 0" descr="The Quotation Checker showing the printed and recalculated grand totals side by side">    </p:cNvPr>
+          <p:cNvPr id="5" name="Image 0" descr="_design/deck/bg/panel.jpg">    </p:cNvPr>
           <p:cNvPicPr>
             <a:picLocks noChangeAspect="1"/>
           </p:cNvPicPr>
@@ -25953,9 +26285,8 @@
         </p:nvPicPr>
         <p:blipFill>
           <a:blip r:embed="rId1"/>
-          <a:stretch>
-            <a:fillRect/>
-          </a:stretch>
+          <a:srcRect l="0" r="0" t="0" b="0"/>
+          <a:stretch/>
         </p:blipFill>
         <p:spPr>
           <a:xfrm>
@@ -25969,29 +26300,63 @@
       </p:pic>
       <p:sp>
         <p:nvSpPr>
-          <p:cNvPr id="6" name="Screenshot border"/>
+          <p:cNvPr id="6" name="Screenshot frame"/>
           <p:cNvSpPr/>
           <p:nvPr/>
         </p:nvSpPr>
         <p:spPr>
           <a:xfrm>
-            <a:off x="548640" y="1783080"/>
-            <a:ext cx="6949440" cy="3909060"/>
-          </a:xfrm>
-          <a:prstGeom prst="rect">
-            <a:avLst/>
-          </a:prstGeom>
-          <a:ln w="12700">
+            <a:off x="804672" y="1927098"/>
+            <a:ext cx="6437376" cy="3621024"/>
+          </a:xfrm>
+          <a:prstGeom prst="rect">
+            <a:avLst/>
+          </a:prstGeom>
+          <a:solidFill>
+            <a:schemeClr val="bg1"/>
+          </a:solidFill>
+          <a:ln w="9525">
             <a:solidFill>
               <a:srgbClr val="E0E0E0"/>
             </a:solidFill>
             <a:prstDash val="solid"/>
           </a:ln>
-        </p:spPr>
-      </p:sp>
-      <p:sp>
-        <p:nvSpPr>
-          <p:cNvPr id="7" name="Text 3"/>
+          <a:effectLst>
+            <a:outerShdw sx="100000" sy="100000" kx="0" ky="0" algn="bl" rotWithShape="0" blurRad="203200" dist="50800" dir="5400000">
+              <a:srgbClr val="1B2A4A">
+                <a:alpha val="25000"/>
+              </a:srgbClr>
+            </a:outerShdw>
+          </a:effectLst>
+        </p:spPr>
+      </p:sp>
+      <p:pic>
+        <p:nvPicPr>
+          <p:cNvPr id="7" name="Image 1" descr="The Quotation Checker showing the printed and recalculated grand totals side by side">    </p:cNvPr>
+          <p:cNvPicPr>
+            <a:picLocks noChangeAspect="1"/>
+          </p:cNvPicPr>
+          <p:nvPr/>
+        </p:nvPicPr>
+        <p:blipFill>
+          <a:blip r:embed="rId2"/>
+          <a:stretch>
+            <a:fillRect/>
+          </a:stretch>
+        </p:blipFill>
+        <p:spPr>
+          <a:xfrm>
+            <a:off x="804672" y="1927098"/>
+            <a:ext cx="6437376" cy="3621024"/>
+          </a:xfrm>
+          <a:prstGeom prst="rect">
+            <a:avLst/>
+          </a:prstGeom>
+        </p:spPr>
+      </p:pic>
+      <p:sp>
+        <p:nvSpPr>
+          <p:cNvPr id="8" name="Text 3"/>
           <p:cNvSpPr txBox="1"/>
           <p:nvPr/>
         </p:nvSpPr>
@@ -26030,7 +26395,7 @@
       </p:sp>
       <p:sp>
         <p:nvSpPr>
-          <p:cNvPr id="8" name="Fix line panel"/>
+          <p:cNvPr id="9" name="Fix line panel"/>
           <p:cNvSpPr/>
           <p:nvPr/>
         </p:nvSpPr>
@@ -26039,18 +26404,27 @@
             <a:off x="7909560" y="2331720"/>
             <a:ext cx="3730752" cy="1920240"/>
           </a:xfrm>
-          <a:prstGeom prst="rect">
-            <a:avLst/>
+          <a:prstGeom prst="roundRect">
+            <a:avLst>
+              <a:gd name="adj" fmla="val 4762"/>
+            </a:avLst>
           </a:prstGeom>
           <a:solidFill>
-            <a:schemeClr val="bg2"/>
+            <a:schemeClr val="bg1"/>
           </a:solidFill>
           <a:ln/>
-        </p:spPr>
-      </p:sp>
-      <p:sp>
-        <p:nvSpPr>
-          <p:cNvPr id="9" name="Text 5"/>
+          <a:effectLst>
+            <a:outerShdw sx="100000" sy="100000" kx="0" ky="0" algn="bl" rotWithShape="0" blurRad="177800" dist="38100" dir="5400000">
+              <a:srgbClr val="1B2A4A">
+                <a:alpha val="12000"/>
+              </a:srgbClr>
+            </a:outerShdw>
+          </a:effectLst>
+        </p:spPr>
+      </p:sp>
+      <p:sp>
+        <p:nvSpPr>
+          <p:cNvPr id="10" name="Text 5"/>
           <p:cNvSpPr txBox="1"/>
           <p:nvPr/>
         </p:nvSpPr>
@@ -26089,7 +26463,7 @@
       </p:sp>
       <p:sp>
         <p:nvSpPr>
-          <p:cNvPr id="10" name="Text 6"/>
+          <p:cNvPr id="11" name="Text 6"/>
           <p:cNvSpPr txBox="1"/>
           <p:nvPr/>
         </p:nvSpPr>
@@ -26198,7 +26572,7 @@
           <p:cNvPr id="2" name="Text 0"/>
           <p:cNvSpPr/>
           <p:nvPr>
-            <p:ph idx="100" type="title" hasCustomPrompt="1"/>
+            <p:ph idx="101" type="title" hasCustomPrompt="1"/>
           </p:nvPr>
         </p:nvSpPr>
         <p:spPr>
@@ -26236,7 +26610,7 @@
           <p:cNvPr id="3" name="Text 0"/>
           <p:cNvSpPr/>
           <p:nvPr>
-            <p:ph idx="101" type="body" hasCustomPrompt="1"/>
+            <p:ph idx="102" type="body" hasCustomPrompt="1"/>
           </p:nvPr>
         </p:nvSpPr>
         <p:spPr>
@@ -26951,13 +27325,22 @@
             <a:off x="7589520" y="1783080"/>
             <a:ext cx="4050792" cy="4160520"/>
           </a:xfrm>
-          <a:prstGeom prst="rect">
-            <a:avLst/>
+          <a:prstGeom prst="roundRect">
+            <a:avLst>
+              <a:gd name="adj" fmla="val 2257"/>
+            </a:avLst>
           </a:prstGeom>
           <a:solidFill>
-            <a:schemeClr val="bg2"/>
+            <a:schemeClr val="bg1"/>
           </a:solidFill>
           <a:ln/>
+          <a:effectLst>
+            <a:outerShdw sx="100000" sy="100000" kx="0" ky="0" algn="bl" rotWithShape="0" blurRad="177800" dist="38100" dir="5400000">
+              <a:srgbClr val="1B2A4A">
+                <a:alpha val="12000"/>
+              </a:srgbClr>
+            </a:outerShdw>
+          </a:effectLst>
         </p:spPr>
       </p:sp>
       <p:pic>
@@ -27207,7 +27590,7 @@
           <p:cNvPr id="2" name="Text 0"/>
           <p:cNvSpPr/>
           <p:nvPr>
-            <p:ph idx="100" type="body" hasCustomPrompt="1"/>
+            <p:ph idx="101" type="body" hasCustomPrompt="1"/>
           </p:nvPr>
         </p:nvSpPr>
         <p:spPr>
@@ -27231,7 +27614,7 @@
             <a:r>
               <a:rPr lang="en-US" sz="8800" dirty="0">
                 <a:solidFill>
-                  <a:schemeClr val="bg1"/>
+                  <a:srgbClr val="00EEFC"/>
                 </a:solidFill>
                 <a:latin typeface="Segoe UI Light" pitchFamily="34" charset="0"/>
                 <a:ea typeface="Segoe UI Light" pitchFamily="34" charset="-122"/>
@@ -27248,7 +27631,7 @@
           <p:cNvPr id="3" name="Text 0"/>
           <p:cNvSpPr/>
           <p:nvPr>
-            <p:ph idx="101" type="title" hasCustomPrompt="1"/>
+            <p:ph idx="102" type="title" hasCustomPrompt="1"/>
           </p:nvPr>
         </p:nvSpPr>
         <p:spPr>
@@ -27286,13 +27669,13 @@
           <p:cNvPr id="4" name="Text 0"/>
           <p:cNvSpPr/>
           <p:nvPr>
-            <p:ph idx="102" type="body" hasCustomPrompt="1"/>
+            <p:ph idx="103" type="body" hasCustomPrompt="1"/>
           </p:nvPr>
         </p:nvSpPr>
         <p:spPr>
           <a:xfrm>
             <a:off x="731520" y="3931920"/>
-            <a:ext cx="9144000" cy="1463040"/>
+            <a:ext cx="6949440" cy="1463040"/>
           </a:xfrm>
           <a:prstGeom prst="rect">
             <a:avLst/>
@@ -28133,7 +28516,7 @@
           <p:cNvPr id="2" name="Text 0"/>
           <p:cNvSpPr/>
           <p:nvPr>
-            <p:ph idx="100" type="body" hasCustomPrompt="1"/>
+            <p:ph idx="101" type="body" hasCustomPrompt="1"/>
           </p:nvPr>
         </p:nvSpPr>
         <p:spPr>
@@ -28157,7 +28540,7 @@
             <a:r>
               <a:rPr lang="en-US" sz="8800" dirty="0">
                 <a:solidFill>
-                  <a:schemeClr val="bg1"/>
+                  <a:srgbClr val="00EEFC"/>
                 </a:solidFill>
                 <a:latin typeface="Segoe UI Light" pitchFamily="34" charset="0"/>
                 <a:ea typeface="Segoe UI Light" pitchFamily="34" charset="-122"/>
@@ -28174,7 +28557,7 @@
           <p:cNvPr id="3" name="Text 0"/>
           <p:cNvSpPr/>
           <p:nvPr>
-            <p:ph idx="101" type="title" hasCustomPrompt="1"/>
+            <p:ph idx="102" type="title" hasCustomPrompt="1"/>
           </p:nvPr>
         </p:nvSpPr>
         <p:spPr>
@@ -28212,13 +28595,13 @@
           <p:cNvPr id="4" name="Text 0"/>
           <p:cNvSpPr/>
           <p:nvPr>
-            <p:ph idx="102" type="body" hasCustomPrompt="1"/>
+            <p:ph idx="103" type="body" hasCustomPrompt="1"/>
           </p:nvPr>
         </p:nvSpPr>
         <p:spPr>
           <a:xfrm>
             <a:off x="731520" y="3931920"/>
-            <a:ext cx="9144000" cy="1463040"/>
+            <a:ext cx="6949440" cy="1463040"/>
           </a:xfrm>
           <a:prstGeom prst="rect">
             <a:avLst/>
@@ -29451,13 +29834,22 @@
             <a:off x="7589520" y="1783080"/>
             <a:ext cx="4050792" cy="4160520"/>
           </a:xfrm>
-          <a:prstGeom prst="rect">
-            <a:avLst/>
+          <a:prstGeom prst="roundRect">
+            <a:avLst>
+              <a:gd name="adj" fmla="val 2257"/>
+            </a:avLst>
           </a:prstGeom>
           <a:solidFill>
-            <a:schemeClr val="bg2"/>
+            <a:schemeClr val="bg1"/>
           </a:solidFill>
           <a:ln/>
+          <a:effectLst>
+            <a:outerShdw sx="100000" sy="100000" kx="0" ky="0" algn="bl" rotWithShape="0" blurRad="177800" dist="38100" dir="5400000">
+              <a:srgbClr val="1B2A4A">
+                <a:alpha val="12000"/>
+              </a:srgbClr>
+            </a:outerShdw>
+          </a:effectLst>
         </p:spPr>
       </p:sp>
       <p:pic>
@@ -31586,7 +31978,7 @@
           <p:cNvPr id="2" name="Text 0"/>
           <p:cNvSpPr/>
           <p:nvPr>
-            <p:ph idx="100" type="body" hasCustomPrompt="1"/>
+            <p:ph idx="101" type="body" hasCustomPrompt="1"/>
           </p:nvPr>
         </p:nvSpPr>
         <p:spPr>
@@ -31610,7 +32002,7 @@
             <a:r>
               <a:rPr lang="en-US" sz="1600" dirty="0">
                 <a:solidFill>
-                  <a:schemeClr val="bg2"/>
+                  <a:srgbClr val="00EEFC"/>
                 </a:solidFill>
               </a:rPr>
               <a:t>Thank you</a:t>
@@ -31624,7 +32016,7 @@
           <p:cNvPr id="3" name="Text 0"/>
           <p:cNvSpPr/>
           <p:nvPr>
-            <p:ph idx="101" type="title" hasCustomPrompt="1"/>
+            <p:ph idx="102" type="title" hasCustomPrompt="1"/>
           </p:nvPr>
         </p:nvSpPr>
         <p:spPr>
@@ -31662,7 +32054,7 @@
           <p:cNvPr id="4" name="Text 0"/>
           <p:cNvSpPr/>
           <p:nvPr>
-            <p:ph idx="102" type="body" hasCustomPrompt="1"/>
+            <p:ph idx="103" type="body" hasCustomPrompt="1"/>
           </p:nvPr>
         </p:nvSpPr>
         <p:spPr>
@@ -31700,7 +32092,7 @@
           <p:cNvPr id="5" name="Text 0"/>
           <p:cNvSpPr/>
           <p:nvPr>
-            <p:ph idx="103" type="body" hasCustomPrompt="1"/>
+            <p:ph idx="104" type="body" hasCustomPrompt="1"/>
           </p:nvPr>
         </p:nvSpPr>
         <p:spPr>
@@ -32305,7 +32697,7 @@
           <p:cNvPr id="2" name="Text 0"/>
           <p:cNvSpPr/>
           <p:nvPr>
-            <p:ph idx="100" type="body" hasCustomPrompt="1"/>
+            <p:ph idx="101" type="body" hasCustomPrompt="1"/>
           </p:nvPr>
         </p:nvSpPr>
         <p:spPr>
@@ -32329,7 +32721,7 @@
             <a:r>
               <a:rPr lang="en-US" sz="8800" dirty="0">
                 <a:solidFill>
-                  <a:schemeClr val="bg1"/>
+                  <a:srgbClr val="00EEFC"/>
                 </a:solidFill>
                 <a:latin typeface="Segoe UI Light" pitchFamily="34" charset="0"/>
                 <a:ea typeface="Segoe UI Light" pitchFamily="34" charset="-122"/>
@@ -32346,7 +32738,7 @@
           <p:cNvPr id="3" name="Text 0"/>
           <p:cNvSpPr/>
           <p:nvPr>
-            <p:ph idx="101" type="title" hasCustomPrompt="1"/>
+            <p:ph idx="102" type="title" hasCustomPrompt="1"/>
           </p:nvPr>
         </p:nvSpPr>
         <p:spPr>
@@ -32384,13 +32776,13 @@
           <p:cNvPr id="4" name="Text 0"/>
           <p:cNvSpPr/>
           <p:nvPr>
-            <p:ph idx="102" type="body" hasCustomPrompt="1"/>
+            <p:ph idx="103" type="body" hasCustomPrompt="1"/>
           </p:nvPr>
         </p:nvSpPr>
         <p:spPr>
           <a:xfrm>
             <a:off x="731520" y="3931920"/>
-            <a:ext cx="9144000" cy="1463040"/>
+            <a:ext cx="6949440" cy="1463040"/>
           </a:xfrm>
           <a:prstGeom prst="rect">
             <a:avLst/>
@@ -32661,7 +33053,7 @@
                     </a:lnT>
                     <a:lnB w="25400" cap="flat" cmpd="sng" algn="ctr">
                       <a:solidFill>
-                        <a:srgbClr val="242424"/>
+                        <a:srgbClr val="1A1A2E"/>
                       </a:solidFill>
                       <a:prstDash val="solid"/>
                       <a:round/>
@@ -32708,7 +33100,7 @@
                     </a:lnT>
                     <a:lnB w="25400" cap="flat" cmpd="sng" algn="ctr">
                       <a:solidFill>
-                        <a:srgbClr val="242424"/>
+                        <a:srgbClr val="1A1A2E"/>
                       </a:solidFill>
                       <a:prstDash val="solid"/>
                       <a:round/>
@@ -32755,7 +33147,7 @@
                     </a:lnT>
                     <a:lnB w="25400" cap="flat" cmpd="sng" algn="ctr">
                       <a:solidFill>
-                        <a:srgbClr val="242424"/>
+                        <a:srgbClr val="1A1A2E"/>
                       </a:solidFill>
                       <a:prstDash val="solid"/>
                       <a:round/>
@@ -32802,7 +33194,7 @@
                     </a:lnT>
                     <a:lnB w="25400" cap="flat" cmpd="sng" algn="ctr">
                       <a:solidFill>
-                        <a:srgbClr val="242424"/>
+                        <a:srgbClr val="1A1A2E"/>
                       </a:solidFill>
                       <a:prstDash val="solid"/>
                       <a:round/>
@@ -33334,13 +33726,22 @@
             <a:off x="548640" y="4617720"/>
             <a:ext cx="11064240" cy="1325880"/>
           </a:xfrm>
-          <a:prstGeom prst="rect">
-            <a:avLst/>
+          <a:prstGeom prst="roundRect">
+            <a:avLst>
+              <a:gd name="adj" fmla="val 6897"/>
+            </a:avLst>
           </a:prstGeom>
           <a:solidFill>
-            <a:schemeClr val="bg2"/>
+            <a:schemeClr val="bg1"/>
           </a:solidFill>
           <a:ln/>
+          <a:effectLst>
+            <a:outerShdw sx="100000" sy="100000" kx="0" ky="0" algn="bl" rotWithShape="0" blurRad="177800" dist="38100" dir="5400000">
+              <a:srgbClr val="1B2A4A">
+                <a:alpha val="12000"/>
+              </a:srgbClr>
+            </a:outerShdw>
+          </a:effectLst>
         </p:spPr>
       </p:sp>
       <p:pic>
@@ -33568,7 +33969,7 @@
       </p:sp>
       <p:pic>
         <p:nvPicPr>
-          <p:cNvPr id="5" name="Image 0" descr="The Copilot app with the green shield at the top right and its tooltip">    </p:cNvPr>
+          <p:cNvPr id="5" name="Image 0" descr="_design/deck/bg/panel.jpg">    </p:cNvPr>
           <p:cNvPicPr>
             <a:picLocks noChangeAspect="1"/>
           </p:cNvPicPr>
@@ -33576,9 +33977,8 @@
         </p:nvPicPr>
         <p:blipFill>
           <a:blip r:embed="rId1"/>
-          <a:stretch>
-            <a:fillRect/>
-          </a:stretch>
+          <a:srcRect l="0" r="0" t="0" b="0"/>
+          <a:stretch/>
         </p:blipFill>
         <p:spPr>
           <a:xfrm>
@@ -33592,29 +33992,63 @@
       </p:pic>
       <p:sp>
         <p:nvSpPr>
-          <p:cNvPr id="6" name="Screenshot border"/>
+          <p:cNvPr id="6" name="Screenshot frame"/>
           <p:cNvSpPr/>
           <p:nvPr/>
         </p:nvSpPr>
         <p:spPr>
           <a:xfrm>
-            <a:off x="548640" y="1783080"/>
-            <a:ext cx="6949440" cy="3909060"/>
-          </a:xfrm>
-          <a:prstGeom prst="rect">
-            <a:avLst/>
-          </a:prstGeom>
-          <a:ln w="12700">
+            <a:off x="804672" y="1927098"/>
+            <a:ext cx="6437376" cy="3621024"/>
+          </a:xfrm>
+          <a:prstGeom prst="rect">
+            <a:avLst/>
+          </a:prstGeom>
+          <a:solidFill>
+            <a:schemeClr val="bg1"/>
+          </a:solidFill>
+          <a:ln w="9525">
             <a:solidFill>
               <a:srgbClr val="E0E0E0"/>
             </a:solidFill>
             <a:prstDash val="solid"/>
           </a:ln>
-        </p:spPr>
-      </p:sp>
-      <p:sp>
-        <p:nvSpPr>
-          <p:cNvPr id="7" name="Text 3"/>
+          <a:effectLst>
+            <a:outerShdw sx="100000" sy="100000" kx="0" ky="0" algn="bl" rotWithShape="0" blurRad="203200" dist="50800" dir="5400000">
+              <a:srgbClr val="1B2A4A">
+                <a:alpha val="25000"/>
+              </a:srgbClr>
+            </a:outerShdw>
+          </a:effectLst>
+        </p:spPr>
+      </p:sp>
+      <p:pic>
+        <p:nvPicPr>
+          <p:cNvPr id="7" name="Image 1" descr="The Copilot app with the green shield at the top right and its tooltip">    </p:cNvPr>
+          <p:cNvPicPr>
+            <a:picLocks noChangeAspect="1"/>
+          </p:cNvPicPr>
+          <p:nvPr/>
+        </p:nvPicPr>
+        <p:blipFill>
+          <a:blip r:embed="rId2"/>
+          <a:stretch>
+            <a:fillRect/>
+          </a:stretch>
+        </p:blipFill>
+        <p:spPr>
+          <a:xfrm>
+            <a:off x="804672" y="1927098"/>
+            <a:ext cx="6437376" cy="3621024"/>
+          </a:xfrm>
+          <a:prstGeom prst="rect">
+            <a:avLst/>
+          </a:prstGeom>
+        </p:spPr>
+      </p:pic>
+      <p:sp>
+        <p:nvSpPr>
+          <p:cNvPr id="8" name="Text 3"/>
           <p:cNvSpPr txBox="1"/>
           <p:nvPr/>
         </p:nvSpPr>
@@ -33653,7 +34087,7 @@
       </p:sp>
       <p:sp>
         <p:nvSpPr>
-          <p:cNvPr id="8" name="Text 4"/>
+          <p:cNvPr id="9" name="Text 4"/>
           <p:cNvSpPr txBox="1"/>
           <p:nvPr/>
         </p:nvSpPr>
@@ -33689,7 +34123,7 @@
       </p:sp>
       <p:sp>
         <p:nvSpPr>
-          <p:cNvPr id="9" name="Text 5"/>
+          <p:cNvPr id="10" name="Text 5"/>
           <p:cNvSpPr txBox="1"/>
           <p:nvPr/>
         </p:nvSpPr>
@@ -33728,7 +34162,7 @@
       </p:sp>
       <p:sp>
         <p:nvSpPr>
-          <p:cNvPr id="10" name="Text 6"/>
+          <p:cNvPr id="11" name="Text 6"/>
           <p:cNvSpPr txBox="1"/>
           <p:nvPr/>
         </p:nvSpPr>
@@ -33764,7 +34198,7 @@
       </p:sp>
       <p:sp>
         <p:nvSpPr>
-          <p:cNvPr id="11" name="Text 7"/>
+          <p:cNvPr id="12" name="Text 7"/>
           <p:cNvSpPr txBox="1"/>
           <p:nvPr/>
         </p:nvSpPr>
@@ -33803,7 +34237,7 @@
       </p:sp>
       <p:sp>
         <p:nvSpPr>
-          <p:cNvPr id="12" name="Text 8"/>
+          <p:cNvPr id="13" name="Text 8"/>
           <p:cNvSpPr txBox="1"/>
           <p:nvPr/>
         </p:nvSpPr>
@@ -33839,7 +34273,7 @@
       </p:sp>
       <p:sp>
         <p:nvSpPr>
-          <p:cNvPr id="13" name="Text 9"/>
+          <p:cNvPr id="14" name="Text 9"/>
           <p:cNvSpPr txBox="1"/>
           <p:nvPr/>
         </p:nvSpPr>
@@ -33878,7 +34312,7 @@
       </p:sp>
       <p:sp>
         <p:nvSpPr>
-          <p:cNvPr id="14" name="Text 10"/>
+          <p:cNvPr id="15" name="Text 10"/>
           <p:cNvSpPr txBox="1"/>
           <p:nvPr/>
         </p:nvSpPr>
@@ -33970,22 +34404,22 @@
   <a:themeElements>
     <a:clrScheme name="Copilot Chat Basic">
       <a:dk1>
-        <a:srgbClr val="242424"/>
+        <a:srgbClr val="1A1A2E"/>
       </a:dk1>
       <a:lt1>
         <a:srgbClr val="FFFFFF"/>
       </a:lt1>
       <a:dk2>
-        <a:srgbClr val="243A5E"/>
+        <a:srgbClr val="1E2761"/>
       </a:dk2>
       <a:lt2>
         <a:srgbClr val="F5F5F5"/>
       </a:lt2>
       <a:accent1>
-        <a:srgbClr val="0078D4"/>
+        <a:srgbClr val="6B5DD3"/>
       </a:accent1>
       <a:accent2>
-        <a:srgbClr val="243A5E"/>
+        <a:srgbClr val="028090"/>
       </a:accent2>
       <a:accent3>
         <a:srgbClr val="D83B01"/>
@@ -34000,10 +34434,10 @@
         <a:srgbClr val="D13438"/>
       </a:accent6>
       <a:hlink>
-        <a:srgbClr val="0078D4"/>
+        <a:srgbClr val="6B5DD3"/>
       </a:hlink>
       <a:folHlink>
-        <a:srgbClr val="243A5E"/>
+        <a:srgbClr val="1E2761"/>
       </a:folHlink>
     </a:clrScheme>
     <a:fontScheme name="Copilot Chat Basic">

</xml_diff>

<commit_message>
Vary the content slide backgrounds in the trainer deck
Four content layouts with different corner and edge art (top-right
ribbon, bottom ribbon, right-edge ribbon, bottom-right rise), rotated
across the content slides. make-backgrounds.py gains vertical ribbons.

Co-Authored-By: Claude Opus 5.5 <noreply@anthropic.com>
Claude-Session: https://claude.ai/code/session_01DQxLb9wMt3kaDj2aX9TSiy
</commit_message>
<xml_diff>
--- a/Copilot-Chat-Basic-Workshop-Deck.pptx
+++ b/Copilot-Chat-Basic-Workshop-Deck.pptx
@@ -156,7 +156,7 @@
   <p:extLst>
     <p:ext uri="{521415D9-36F7-43E2-AB2F-B90AF26B5E84}">
       <p14:sectionLst xmlns:p14="http://schemas.microsoft.com/office/powerpoint/2010/main">
-        <p14:section name="Welcome" id="{fc0325b0-1ad6-e854-78b4-e7b29925407f}">
+        <p14:section name="Welcome" id="{1fda84d4-618e-3fe8-3f06-a122e2a9af38}">
           <p14:sldIdLst>
             <p14:sldId id="256"/>
             <p14:sldId id="257"/>
@@ -166,7 +166,7 @@
             <p14:sldId id="261"/>
           </p14:sldIdLst>
         </p14:section>
-        <p14:section name="01 Which Copilot do I have?" id="{18497dd3-0dcf-5f4a-a772-bb6545c7db02}">
+        <p14:section name="01 Which Copilot do I have?" id="{de54b74a-ce79-39eb-5434-725542b91ff7}">
           <p14:sldIdLst>
             <p14:sldId id="262"/>
             <p14:sldId id="263"/>
@@ -175,7 +175,7 @@
             <p14:sldId id="266"/>
           </p14:sldIdLst>
         </p14:section>
-        <p14:section name="02 Find your way around" id="{e779932c-152c-0da1-4dfc-f836fb3fb178}">
+        <p14:section name="02 Find your way around" id="{a60a54a6-a6ac-5ecd-5f25-9d52ded58361}">
           <p14:sldIdLst>
             <p14:sldId id="267"/>
             <p14:sldId id="268"/>
@@ -183,7 +183,7 @@
             <p14:sldId id="270"/>
           </p14:sldIdLst>
         </p14:section>
-        <p14:section name="03 Write better prompts" id="{940a0c3f-e2dd-758b-0e5a-78538fa06cac}">
+        <p14:section name="03 Write better prompts" id="{dbc1b2a7-88ca-8300-372c-d28a15e3917c}">
           <p14:sldIdLst>
             <p14:sldId id="271"/>
             <p14:sldId id="272"/>
@@ -192,7 +192,7 @@
             <p14:sldId id="275"/>
           </p14:sldIdLst>
         </p14:section>
-        <p14:section name="04 Compare the quotations" id="{73f212ea-1e8d-6a7e-66df-ed3fb1d603c5}">
+        <p14:section name="04 Compare the quotations" id="{4b1a9fa3-8cd4-9f1a-768c-cf8d54c37eee}">
           <p14:sldIdLst>
             <p14:sldId id="276"/>
             <p14:sldId id="277"/>
@@ -202,7 +202,7 @@
             <p14:sldId id="281"/>
           </p14:sldIdLst>
         </p14:section>
-        <p14:section name="05 Chase vendors in Outlook" id="{97f594dc-2347-380a-3da4-550916f500f7}">
+        <p14:section name="05 Chase vendors in Outlook" id="{e7b44091-1e76-573e-4851-010b2d4ef9f5}">
           <p14:sldIdLst>
             <p14:sldId id="282"/>
             <p14:sldId id="283"/>
@@ -210,7 +210,7 @@
             <p14:sldId id="285"/>
           </p14:sldIdLst>
         </p14:section>
-        <p14:section name="06 From chat to Pages" id="{6b0af65e-f640-afdd-c724-d47e63cc64d3}">
+        <p14:section name="06 From chat to Pages" id="{75433d01-461b-ec97-5bd2-ef1833615c10}">
           <p14:sldIdLst>
             <p14:sldId id="286"/>
             <p14:sldId id="287"/>
@@ -218,14 +218,14 @@
             <p14:sldId id="289"/>
           </p14:sldIdLst>
         </p14:section>
-        <p14:section name="07 Keep it together in a Notebook" id="{1b04bd8a-fab1-c650-e1f9-8823137351f8}">
+        <p14:section name="07 Keep it together in a Notebook" id="{5af7073e-fd59-47f7-e8c8-210d0526e2a1}">
           <p14:sldIdLst>
             <p14:sldId id="290"/>
             <p14:sldId id="291"/>
             <p14:sldId id="292"/>
           </p14:sldIdLst>
         </p14:section>
-        <p14:section name="08 Build a Quotation Checker agent" id="{81bd0ca7-9d55-427d-7034-553733bd03dd}">
+        <p14:section name="08 Build a Quotation Checker agent" id="{d4261562-9e35-d1f9-2ea4-fad363982996}">
           <p14:sldIdLst>
             <p14:sldId id="293"/>
             <p14:sldId id="294"/>
@@ -234,25 +234,25 @@
             <p14:sldId id="297"/>
           </p14:sldIdLst>
         </p14:section>
-        <p14:section name="09 Optional: Word and Excel" id="{8c1b5ade-cb70-f42c-3c0b-462ccab1e194}">
+        <p14:section name="09 Optional: Word and Excel" id="{0dd796bd-3135-a5be-a7f5-927de4a1a7f7}">
           <p14:sldIdLst>
             <p14:sldId id="298"/>
             <p14:sldId id="299"/>
           </p14:sldIdLst>
         </p14:section>
-        <p14:section name="10 Capstone" id="{684ca27b-6bba-4978-164f-0972b9a19426}">
+        <p14:section name="10 Capstone" id="{c20af5e4-d645-976c-35dc-5c8bd08e1e49}">
           <p14:sldIdLst>
             <p14:sldId id="300"/>
             <p14:sldId id="301"/>
             <p14:sldId id="302"/>
           </p14:sldIdLst>
         </p14:section>
-        <p14:section name="11 Extra practice" id="{e1025b9e-fdd8-266d-912c-df5851b5757a}">
+        <p14:section name="11 Extra practice" id="{81cf6ca3-97ff-82f3-6a65-2c71e3e353a3}">
           <p14:sldIdLst>
             <p14:sldId id="303"/>
           </p14:sldIdLst>
         </p14:section>
-        <p14:section name="Close" id="{b1bdc88f-c111-eedf-cc1c-4413f58e6006}">
+        <p14:section name="Close" id="{d10eb72e-9a51-234e-28d4-c4e8bb13a6c7}">
           <p14:sldIdLst>
             <p14:sldId id="304"/>
             <p14:sldId id="305"/>
@@ -5776,6 +5776,672 @@
 
 <file path=ppt/slideLayouts/slideLayout5.xml><?xml version="1.0" encoding="utf-8"?>
 <p:sldLayout xmlns:a="http://schemas.openxmlformats.org/drawingml/2006/main" xmlns:r="http://schemas.openxmlformats.org/officeDocument/2006/relationships" xmlns:p="http://schemas.openxmlformats.org/presentationml/2006/main" preserve="1">
+  <p:cSld name="Content 2">
+    <p:bg>
+      <p:bgPr>
+        <a:blipFill dpi="0" rotWithShape="1">
+          <a:blip r:embed="rId2">
+            <a:lum/>
+          </a:blip>
+          <a:srcRect/>
+          <a:stretch>
+            <a:fillRect/>
+          </a:stretch>
+        </a:blipFill>
+        <a:effectLst/>
+      </p:bgPr>
+    </p:bg>
+    <p:spTree>
+      <p:nvGrpSpPr>
+        <p:cNvPr id="1" name=""/>
+        <p:cNvGrpSpPr/>
+        <p:nvPr/>
+      </p:nvGrpSpPr>
+      <p:grpSpPr>
+        <a:xfrm>
+          <a:off x="0" y="0"/>
+          <a:ext cx="0" cy="0"/>
+          <a:chOff x="0" y="0"/>
+          <a:chExt cx="0" cy="0"/>
+        </a:xfrm>
+      </p:grpSpPr>
+      <p:sp>
+        <p:nvSpPr>
+          <p:cNvPr id="2" name="Text 0"/>
+          <p:cNvSpPr/>
+          <p:nvPr>
+            <p:ph idx="100" type="body" hasCustomPrompt="1"/>
+          </p:nvPr>
+        </p:nvSpPr>
+        <p:spPr>
+          <a:xfrm>
+            <a:off x="548640" y="365760"/>
+            <a:ext cx="10972800" cy="320040"/>
+          </a:xfrm>
+          <a:prstGeom prst="rect">
+            <a:avLst/>
+          </a:prstGeom>
+          <a:noFill/>
+          <a:ln/>
+        </p:spPr>
+        <p:txBody>
+          <a:bodyPr wrap="square" rtlCol="0"/>
+          <a:lstStyle>
+            <a:lvl1pPr indent="0" marL="0">
+              <a:buNone/>
+              <a:defRPr lang="en-US" sz="1400" dirty="0">
+                <a:solidFill>
+                  <a:schemeClr val="accent4"/>
+                </a:solidFill>
+              </a:defRPr>
+            </a:lvl1pPr>
+          </a:lstStyle>
+          <a:p>
+            <a:pPr indent="0" marL="0">
+              <a:buNone/>
+            </a:pPr>
+            <a:endParaRPr lang="en-US" sz="1400" dirty="0"/>
+          </a:p>
+        </p:txBody>
+      </p:sp>
+      <p:sp>
+        <p:nvSpPr>
+          <p:cNvPr id="3" name="Text 0"/>
+          <p:cNvSpPr/>
+          <p:nvPr>
+            <p:ph idx="101" type="title" hasCustomPrompt="1"/>
+          </p:nvPr>
+        </p:nvSpPr>
+        <p:spPr>
+          <a:xfrm>
+            <a:off x="548640" y="685800"/>
+            <a:ext cx="11064240" cy="777240"/>
+          </a:xfrm>
+          <a:prstGeom prst="rect">
+            <a:avLst/>
+          </a:prstGeom>
+          <a:noFill/>
+          <a:ln/>
+        </p:spPr>
+        <p:txBody>
+          <a:bodyPr wrap="square" rtlCol="0"/>
+          <a:lstStyle>
+            <a:lvl1pPr algn="l" indent="0" marL="0">
+              <a:buNone/>
+              <a:defRPr lang="en-US" sz="3200" dirty="0">
+                <a:solidFill>
+                  <a:schemeClr val="tx1"/>
+                </a:solidFill>
+              </a:defRPr>
+            </a:lvl1pPr>
+          </a:lstStyle>
+          <a:p>
+            <a:pPr algn="l" indent="0" marL="0">
+              <a:buNone/>
+            </a:pPr>
+            <a:endParaRPr lang="en-US" sz="3200" dirty="0"/>
+          </a:p>
+        </p:txBody>
+      </p:sp>
+      <p:pic>
+        <p:nvPicPr>
+          <p:cNvPr id="4" name="Image 0" descr="Asraf JS logo">    </p:cNvPr>
+          <p:cNvPicPr>
+            <a:picLocks noChangeAspect="1"/>
+          </p:cNvPicPr>
+          <p:nvPr/>
+        </p:nvPicPr>
+        <p:blipFill>
+          <a:blip r:embed="rId1"/>
+          <a:stretch>
+            <a:fillRect/>
+          </a:stretch>
+        </p:blipFill>
+        <p:spPr>
+          <a:xfrm>
+            <a:off x="502920" y="6245352"/>
+            <a:ext cx="384048" cy="384048"/>
+          </a:xfrm>
+          <a:prstGeom prst="rect">
+            <a:avLst/>
+          </a:prstGeom>
+        </p:spPr>
+      </p:pic>
+      <p:sp>
+        <p:nvSpPr>
+          <p:cNvPr id="5" name="Text 0"/>
+          <p:cNvSpPr/>
+          <p:nvPr/>
+        </p:nvSpPr>
+        <p:spPr>
+          <a:xfrm>
+            <a:off x="960120" y="6355080"/>
+            <a:ext cx="5486400" cy="274320"/>
+          </a:xfrm>
+          <a:prstGeom prst="rect">
+            <a:avLst/>
+          </a:prstGeom>
+          <a:noFill/>
+          <a:ln/>
+        </p:spPr>
+        <p:txBody>
+          <a:bodyPr wrap="square" lIns="0" tIns="0" rIns="0" bIns="0" rtlCol="0" anchor="ctr"/>
+          <a:lstStyle/>
+          <a:p>
+            <a:pPr indent="0" marL="0">
+              <a:buNone/>
+            </a:pPr>
+            <a:r>
+              <a:rPr lang="en-US" sz="1000" dirty="0">
+                <a:solidFill>
+                  <a:schemeClr val="accent4"/>
+                </a:solidFill>
+              </a:rPr>
+              <a:t>Copilot Chat Basic Workshop</a:t>
+            </a:r>
+            <a:endParaRPr lang="en-US" sz="1000" dirty="0"/>
+          </a:p>
+        </p:txBody>
+      </p:sp>
+      <p:sp>
+        <p:nvSpPr>
+          <p:cNvPr id="25" name="Slide Number Placeholder 0"/>
+          <p:cNvSpPr>
+            <a:spLocks noGrp="1"/>
+          </p:cNvSpPr>
+          <p:nvPr>
+            <p:ph type="sldNum" sz="quarter" idx="4294967295"/>
+          </p:nvPr>
+        </p:nvSpPr>
+        <p:spPr>
+          <a:xfrm>
+            <a:off x="11064240" y="6355080"/>
+            <a:ext cx="548640" cy="274320"/>
+          </a:xfrm>
+          <a:prstGeom prst="rect">
+            <a:avLst/>
+          </a:prstGeom>
+          <a:extLst>
+            <a:ext uri="{C572A759-6A51-4108-AA02-DFA0A04FC94B}">
+              <ma14:wrappingTextBoxFlag xmlns:ma14="http://schemas.microsoft.com/office/mac/drawingml/2011/main" val="0"/>
+            </a:ext>
+          </a:extLst>
+        </p:spPr>
+        <p:txBody>
+          <a:bodyPr/>
+          <a:lstStyle>
+            <a:lvl1pPr>
+              <a:defRPr sz="1000">
+                <a:solidFill>
+                  <a:schemeClr val="accent4"/>
+                </a:solidFill>
+              </a:defRPr>
+            </a:lvl1pPr>
+          </a:lstStyle>
+          <a:p>
+            <a:pPr algn="r"/>
+            <a:fld id="{F7021451-1387-4CA6-816F-3879F97B5CBC}" type="slidenum">
+              <a:rPr b="0" lang="en-US"/>
+              <a:t>1005</a:t>
+            </a:fld>
+            <a:endParaRPr lang="en-US"/>
+          </a:p>
+        </p:txBody>
+      </p:sp>
+    </p:spTree>
+  </p:cSld>
+  <p:clrMapOvr>
+    <a:masterClrMapping/>
+  </p:clrMapOvr>
+</p:sldLayout>
+</file>
+
+<file path=ppt/slideLayouts/slideLayout6.xml><?xml version="1.0" encoding="utf-8"?>
+<p:sldLayout xmlns:a="http://schemas.openxmlformats.org/drawingml/2006/main" xmlns:r="http://schemas.openxmlformats.org/officeDocument/2006/relationships" xmlns:p="http://schemas.openxmlformats.org/presentationml/2006/main" preserve="1">
+  <p:cSld name="Content 3">
+    <p:bg>
+      <p:bgPr>
+        <a:blipFill dpi="0" rotWithShape="1">
+          <a:blip r:embed="rId2">
+            <a:lum/>
+          </a:blip>
+          <a:srcRect/>
+          <a:stretch>
+            <a:fillRect/>
+          </a:stretch>
+        </a:blipFill>
+        <a:effectLst/>
+      </p:bgPr>
+    </p:bg>
+    <p:spTree>
+      <p:nvGrpSpPr>
+        <p:cNvPr id="1" name=""/>
+        <p:cNvGrpSpPr/>
+        <p:nvPr/>
+      </p:nvGrpSpPr>
+      <p:grpSpPr>
+        <a:xfrm>
+          <a:off x="0" y="0"/>
+          <a:ext cx="0" cy="0"/>
+          <a:chOff x="0" y="0"/>
+          <a:chExt cx="0" cy="0"/>
+        </a:xfrm>
+      </p:grpSpPr>
+      <p:sp>
+        <p:nvSpPr>
+          <p:cNvPr id="2" name="Text 0"/>
+          <p:cNvSpPr/>
+          <p:nvPr>
+            <p:ph idx="100" type="body" hasCustomPrompt="1"/>
+          </p:nvPr>
+        </p:nvSpPr>
+        <p:spPr>
+          <a:xfrm>
+            <a:off x="548640" y="365760"/>
+            <a:ext cx="10972800" cy="320040"/>
+          </a:xfrm>
+          <a:prstGeom prst="rect">
+            <a:avLst/>
+          </a:prstGeom>
+          <a:noFill/>
+          <a:ln/>
+        </p:spPr>
+        <p:txBody>
+          <a:bodyPr wrap="square" rtlCol="0"/>
+          <a:lstStyle>
+            <a:lvl1pPr indent="0" marL="0">
+              <a:buNone/>
+              <a:defRPr lang="en-US" sz="1400" dirty="0">
+                <a:solidFill>
+                  <a:schemeClr val="accent4"/>
+                </a:solidFill>
+              </a:defRPr>
+            </a:lvl1pPr>
+          </a:lstStyle>
+          <a:p>
+            <a:pPr indent="0" marL="0">
+              <a:buNone/>
+            </a:pPr>
+            <a:endParaRPr lang="en-US" sz="1400" dirty="0"/>
+          </a:p>
+        </p:txBody>
+      </p:sp>
+      <p:sp>
+        <p:nvSpPr>
+          <p:cNvPr id="3" name="Text 0"/>
+          <p:cNvSpPr/>
+          <p:nvPr>
+            <p:ph idx="101" type="title" hasCustomPrompt="1"/>
+          </p:nvPr>
+        </p:nvSpPr>
+        <p:spPr>
+          <a:xfrm>
+            <a:off x="548640" y="685800"/>
+            <a:ext cx="11064240" cy="777240"/>
+          </a:xfrm>
+          <a:prstGeom prst="rect">
+            <a:avLst/>
+          </a:prstGeom>
+          <a:noFill/>
+          <a:ln/>
+        </p:spPr>
+        <p:txBody>
+          <a:bodyPr wrap="square" rtlCol="0"/>
+          <a:lstStyle>
+            <a:lvl1pPr algn="l" indent="0" marL="0">
+              <a:buNone/>
+              <a:defRPr lang="en-US" sz="3200" dirty="0">
+                <a:solidFill>
+                  <a:schemeClr val="tx1"/>
+                </a:solidFill>
+              </a:defRPr>
+            </a:lvl1pPr>
+          </a:lstStyle>
+          <a:p>
+            <a:pPr algn="l" indent="0" marL="0">
+              <a:buNone/>
+            </a:pPr>
+            <a:endParaRPr lang="en-US" sz="3200" dirty="0"/>
+          </a:p>
+        </p:txBody>
+      </p:sp>
+      <p:pic>
+        <p:nvPicPr>
+          <p:cNvPr id="4" name="Image 0" descr="Asraf JS logo">    </p:cNvPr>
+          <p:cNvPicPr>
+            <a:picLocks noChangeAspect="1"/>
+          </p:cNvPicPr>
+          <p:nvPr/>
+        </p:nvPicPr>
+        <p:blipFill>
+          <a:blip r:embed="rId1"/>
+          <a:stretch>
+            <a:fillRect/>
+          </a:stretch>
+        </p:blipFill>
+        <p:spPr>
+          <a:xfrm>
+            <a:off x="502920" y="6245352"/>
+            <a:ext cx="384048" cy="384048"/>
+          </a:xfrm>
+          <a:prstGeom prst="rect">
+            <a:avLst/>
+          </a:prstGeom>
+        </p:spPr>
+      </p:pic>
+      <p:sp>
+        <p:nvSpPr>
+          <p:cNvPr id="5" name="Text 0"/>
+          <p:cNvSpPr/>
+          <p:nvPr/>
+        </p:nvSpPr>
+        <p:spPr>
+          <a:xfrm>
+            <a:off x="960120" y="6355080"/>
+            <a:ext cx="5486400" cy="274320"/>
+          </a:xfrm>
+          <a:prstGeom prst="rect">
+            <a:avLst/>
+          </a:prstGeom>
+          <a:noFill/>
+          <a:ln/>
+        </p:spPr>
+        <p:txBody>
+          <a:bodyPr wrap="square" lIns="0" tIns="0" rIns="0" bIns="0" rtlCol="0" anchor="ctr"/>
+          <a:lstStyle/>
+          <a:p>
+            <a:pPr indent="0" marL="0">
+              <a:buNone/>
+            </a:pPr>
+            <a:r>
+              <a:rPr lang="en-US" sz="1000" dirty="0">
+                <a:solidFill>
+                  <a:schemeClr val="accent4"/>
+                </a:solidFill>
+              </a:rPr>
+              <a:t>Copilot Chat Basic Workshop</a:t>
+            </a:r>
+            <a:endParaRPr lang="en-US" sz="1000" dirty="0"/>
+          </a:p>
+        </p:txBody>
+      </p:sp>
+      <p:sp>
+        <p:nvSpPr>
+          <p:cNvPr id="25" name="Slide Number Placeholder 0"/>
+          <p:cNvSpPr>
+            <a:spLocks noGrp="1"/>
+          </p:cNvSpPr>
+          <p:nvPr>
+            <p:ph type="sldNum" sz="quarter" idx="4294967295"/>
+          </p:nvPr>
+        </p:nvSpPr>
+        <p:spPr>
+          <a:xfrm>
+            <a:off x="11064240" y="6355080"/>
+            <a:ext cx="548640" cy="274320"/>
+          </a:xfrm>
+          <a:prstGeom prst="rect">
+            <a:avLst/>
+          </a:prstGeom>
+          <a:extLst>
+            <a:ext uri="{C572A759-6A51-4108-AA02-DFA0A04FC94B}">
+              <ma14:wrappingTextBoxFlag xmlns:ma14="http://schemas.microsoft.com/office/mac/drawingml/2011/main" val="0"/>
+            </a:ext>
+          </a:extLst>
+        </p:spPr>
+        <p:txBody>
+          <a:bodyPr/>
+          <a:lstStyle>
+            <a:lvl1pPr>
+              <a:defRPr sz="1000">
+                <a:solidFill>
+                  <a:schemeClr val="accent4"/>
+                </a:solidFill>
+              </a:defRPr>
+            </a:lvl1pPr>
+          </a:lstStyle>
+          <a:p>
+            <a:pPr algn="r"/>
+            <a:fld id="{F7021451-1387-4CA6-816F-3879F97B5CBC}" type="slidenum">
+              <a:rPr b="0" lang="en-US"/>
+              <a:t>1006</a:t>
+            </a:fld>
+            <a:endParaRPr lang="en-US"/>
+          </a:p>
+        </p:txBody>
+      </p:sp>
+    </p:spTree>
+  </p:cSld>
+  <p:clrMapOvr>
+    <a:masterClrMapping/>
+  </p:clrMapOvr>
+</p:sldLayout>
+</file>
+
+<file path=ppt/slideLayouts/slideLayout7.xml><?xml version="1.0" encoding="utf-8"?>
+<p:sldLayout xmlns:a="http://schemas.openxmlformats.org/drawingml/2006/main" xmlns:r="http://schemas.openxmlformats.org/officeDocument/2006/relationships" xmlns:p="http://schemas.openxmlformats.org/presentationml/2006/main" preserve="1">
+  <p:cSld name="Content 4">
+    <p:bg>
+      <p:bgPr>
+        <a:blipFill dpi="0" rotWithShape="1">
+          <a:blip r:embed="rId2">
+            <a:lum/>
+          </a:blip>
+          <a:srcRect/>
+          <a:stretch>
+            <a:fillRect/>
+          </a:stretch>
+        </a:blipFill>
+        <a:effectLst/>
+      </p:bgPr>
+    </p:bg>
+    <p:spTree>
+      <p:nvGrpSpPr>
+        <p:cNvPr id="1" name=""/>
+        <p:cNvGrpSpPr/>
+        <p:nvPr/>
+      </p:nvGrpSpPr>
+      <p:grpSpPr>
+        <a:xfrm>
+          <a:off x="0" y="0"/>
+          <a:ext cx="0" cy="0"/>
+          <a:chOff x="0" y="0"/>
+          <a:chExt cx="0" cy="0"/>
+        </a:xfrm>
+      </p:grpSpPr>
+      <p:sp>
+        <p:nvSpPr>
+          <p:cNvPr id="2" name="Text 0"/>
+          <p:cNvSpPr/>
+          <p:nvPr>
+            <p:ph idx="100" type="body" hasCustomPrompt="1"/>
+          </p:nvPr>
+        </p:nvSpPr>
+        <p:spPr>
+          <a:xfrm>
+            <a:off x="548640" y="365760"/>
+            <a:ext cx="10972800" cy="320040"/>
+          </a:xfrm>
+          <a:prstGeom prst="rect">
+            <a:avLst/>
+          </a:prstGeom>
+          <a:noFill/>
+          <a:ln/>
+        </p:spPr>
+        <p:txBody>
+          <a:bodyPr wrap="square" rtlCol="0"/>
+          <a:lstStyle>
+            <a:lvl1pPr indent="0" marL="0">
+              <a:buNone/>
+              <a:defRPr lang="en-US" sz="1400" dirty="0">
+                <a:solidFill>
+                  <a:schemeClr val="accent4"/>
+                </a:solidFill>
+              </a:defRPr>
+            </a:lvl1pPr>
+          </a:lstStyle>
+          <a:p>
+            <a:pPr indent="0" marL="0">
+              <a:buNone/>
+            </a:pPr>
+            <a:endParaRPr lang="en-US" sz="1400" dirty="0"/>
+          </a:p>
+        </p:txBody>
+      </p:sp>
+      <p:sp>
+        <p:nvSpPr>
+          <p:cNvPr id="3" name="Text 0"/>
+          <p:cNvSpPr/>
+          <p:nvPr>
+            <p:ph idx="101" type="title" hasCustomPrompt="1"/>
+          </p:nvPr>
+        </p:nvSpPr>
+        <p:spPr>
+          <a:xfrm>
+            <a:off x="548640" y="685800"/>
+            <a:ext cx="11064240" cy="777240"/>
+          </a:xfrm>
+          <a:prstGeom prst="rect">
+            <a:avLst/>
+          </a:prstGeom>
+          <a:noFill/>
+          <a:ln/>
+        </p:spPr>
+        <p:txBody>
+          <a:bodyPr wrap="square" rtlCol="0"/>
+          <a:lstStyle>
+            <a:lvl1pPr algn="l" indent="0" marL="0">
+              <a:buNone/>
+              <a:defRPr lang="en-US" sz="3200" dirty="0">
+                <a:solidFill>
+                  <a:schemeClr val="tx1"/>
+                </a:solidFill>
+              </a:defRPr>
+            </a:lvl1pPr>
+          </a:lstStyle>
+          <a:p>
+            <a:pPr algn="l" indent="0" marL="0">
+              <a:buNone/>
+            </a:pPr>
+            <a:endParaRPr lang="en-US" sz="3200" dirty="0"/>
+          </a:p>
+        </p:txBody>
+      </p:sp>
+      <p:pic>
+        <p:nvPicPr>
+          <p:cNvPr id="4" name="Image 0" descr="Asraf JS logo">    </p:cNvPr>
+          <p:cNvPicPr>
+            <a:picLocks noChangeAspect="1"/>
+          </p:cNvPicPr>
+          <p:nvPr/>
+        </p:nvPicPr>
+        <p:blipFill>
+          <a:blip r:embed="rId1"/>
+          <a:stretch>
+            <a:fillRect/>
+          </a:stretch>
+        </p:blipFill>
+        <p:spPr>
+          <a:xfrm>
+            <a:off x="502920" y="6245352"/>
+            <a:ext cx="384048" cy="384048"/>
+          </a:xfrm>
+          <a:prstGeom prst="rect">
+            <a:avLst/>
+          </a:prstGeom>
+        </p:spPr>
+      </p:pic>
+      <p:sp>
+        <p:nvSpPr>
+          <p:cNvPr id="5" name="Text 0"/>
+          <p:cNvSpPr/>
+          <p:nvPr/>
+        </p:nvSpPr>
+        <p:spPr>
+          <a:xfrm>
+            <a:off x="960120" y="6355080"/>
+            <a:ext cx="5486400" cy="274320"/>
+          </a:xfrm>
+          <a:prstGeom prst="rect">
+            <a:avLst/>
+          </a:prstGeom>
+          <a:noFill/>
+          <a:ln/>
+        </p:spPr>
+        <p:txBody>
+          <a:bodyPr wrap="square" lIns="0" tIns="0" rIns="0" bIns="0" rtlCol="0" anchor="ctr"/>
+          <a:lstStyle/>
+          <a:p>
+            <a:pPr indent="0" marL="0">
+              <a:buNone/>
+            </a:pPr>
+            <a:r>
+              <a:rPr lang="en-US" sz="1000" dirty="0">
+                <a:solidFill>
+                  <a:schemeClr val="accent4"/>
+                </a:solidFill>
+              </a:rPr>
+              <a:t>Copilot Chat Basic Workshop</a:t>
+            </a:r>
+            <a:endParaRPr lang="en-US" sz="1000" dirty="0"/>
+          </a:p>
+        </p:txBody>
+      </p:sp>
+      <p:sp>
+        <p:nvSpPr>
+          <p:cNvPr id="25" name="Slide Number Placeholder 0"/>
+          <p:cNvSpPr>
+            <a:spLocks noGrp="1"/>
+          </p:cNvSpPr>
+          <p:nvPr>
+            <p:ph type="sldNum" sz="quarter" idx="4294967295"/>
+          </p:nvPr>
+        </p:nvSpPr>
+        <p:spPr>
+          <a:xfrm>
+            <a:off x="11064240" y="6355080"/>
+            <a:ext cx="548640" cy="274320"/>
+          </a:xfrm>
+          <a:prstGeom prst="rect">
+            <a:avLst/>
+          </a:prstGeom>
+          <a:extLst>
+            <a:ext uri="{C572A759-6A51-4108-AA02-DFA0A04FC94B}">
+              <ma14:wrappingTextBoxFlag xmlns:ma14="http://schemas.microsoft.com/office/mac/drawingml/2011/main" val="0"/>
+            </a:ext>
+          </a:extLst>
+        </p:spPr>
+        <p:txBody>
+          <a:bodyPr/>
+          <a:lstStyle>
+            <a:lvl1pPr>
+              <a:defRPr sz="1000">
+                <a:solidFill>
+                  <a:schemeClr val="accent4"/>
+                </a:solidFill>
+              </a:defRPr>
+            </a:lvl1pPr>
+          </a:lstStyle>
+          <a:p>
+            <a:pPr algn="r"/>
+            <a:fld id="{F7021451-1387-4CA6-816F-3879F97B5CBC}" type="slidenum">
+              <a:rPr b="0" lang="en-US"/>
+              <a:t>1007</a:t>
+            </a:fld>
+            <a:endParaRPr lang="en-US"/>
+          </a:p>
+        </p:txBody>
+      </p:sp>
+    </p:spTree>
+  </p:cSld>
+  <p:clrMapOvr>
+    <a:masterClrMapping/>
+  </p:clrMapOvr>
+</p:sldLayout>
+</file>
+
+<file path=ppt/slideLayouts/slideLayout8.xml><?xml version="1.0" encoding="utf-8"?>
+<p:sldLayout xmlns:a="http://schemas.openxmlformats.org/drawingml/2006/main" xmlns:r="http://schemas.openxmlformats.org/officeDocument/2006/relationships" xmlns:p="http://schemas.openxmlformats.org/presentationml/2006/main" preserve="1">
   <p:cSld name="Statement">
     <p:bg>
       <p:bgPr>
@@ -5946,7 +6612,7 @@
             <a:pPr algn="r"/>
             <a:fld id="{F7021451-1387-4CA6-816F-3879F97B5CBC}" type="slidenum">
               <a:rPr b="0" lang="en-US"/>
-              <a:t>1005</a:t>
+              <a:t>1008</a:t>
             </a:fld>
             <a:endParaRPr lang="en-US"/>
           </a:p>
@@ -6031,6 +6697,9 @@
     <p:sldLayoutId id="2147483651" r:id="rId3"/>
     <p:sldLayoutId id="2147483652" r:id="rId4"/>
     <p:sldLayoutId id="2147483653" r:id="rId5"/>
+    <p:sldLayoutId id="2147483654" r:id="rId6"/>
+    <p:sldLayoutId id="2147483655" r:id="rId7"/>
+    <p:sldLayoutId id="2147483656" r:id="rId8"/>
   </p:sldLayoutIdLst>
   <p:hf sldNum="0" hdr="0" ftr="0" dt="0"/>
   <p:txStyles>

</xml_diff>